<commit_message>
docs(exp52): GS Mapping 루프 최대 세분화(12단계) + PPT 정정판 재생성
process_track_data() 전체(pose/scale 업데이트·camera 생성·add_next_kf 등 map()
바깥 부가작업)까지 계측 범위를 넓혀 12단계로 세분화. rasterize+backward+
loss_compute가 81.4%로 여전히 지배적, 부가작업은 4.2%뿐(가설과 달리 무시할
수준). map() 내부에서 기존 5단계 합과 총합 사이 12.0초(12.9%)의 새 미계측
포켓을 발견(isotropic loss 계산+viewpoint 샘플링으로 추정, 다음 계측 후보).

ppt0720 덱을 타이밍 버그 정정 수치(150.56s/98.94s/88.3%/1.52배)로 전면
재생성하고 신규 슬라이드 2개(정정 요약, GS Mapping 12단계 세분화) 추가.

Co-Authored-By: Claude Sonnet 5 <noreply@anthropic.com>
Claude-Session: https://claude.ai/code/session_01S3XAkMSxa2MGHVvbytmKvK
</commit_message>
<xml_diff>
--- a/context/ppt/ppt0720/vigs_realtime_timeline_0720.pptx
+++ b/context/ppt/ppt0720/vigs_realtime_timeline_0720.pptx
@@ -13,6 +13,8 @@
     <p:sldId id="261" r:id="rId12"/>
     <p:sldId id="262" r:id="rId13"/>
     <p:sldId id="263" r:id="rId14"/>
+    <p:sldId id="264" r:id="rId15"/>
+    <p:sldId id="265" r:id="rId16"/>
   </p:sldIdLst>
   <p:sldSz cx="12191695" cy="6858000" type="screen4x3"/>
   <p:notesSz cx="6858000" cy="9144000"/>
@@ -3173,7 +3175,7 @@
                 </a:solidFill>
                 <a:latin typeface="Noto Sans CJK KR"/>
               </a:rPr>
-              <a:t>EXP52 / EXP53 · GS_FLOATERLAB</a:t>
+              <a:t>EXP52 / EXP53 · GS_FLOATERLAB · 정정판</a:t>
             </a:r>
           </a:p>
         </p:txBody>
@@ -3290,7 +3292,254 @@
                 </a:solidFill>
                 <a:latin typeface="Noto Sans CJK KR"/>
               </a:rPr>
-              <a:t>1253 시퀀스 · 65.1초 실녹화 · imu_cpp+TensorRT 가속 적용 · 2026-07-20</a:t>
+              <a:t>1253 시퀀스 · 65.1초 실녹화 · imu_cpp+TensorRT 가속 적용 · 타이밍 버그 수정 후 재검증 · 2026-07-20</a:t>
+            </a:r>
+          </a:p>
+        </p:txBody>
+      </p:sp>
+    </p:spTree>
+  </p:cSld>
+  <p:clrMapOvr>
+    <a:masterClrMapping/>
+  </p:clrMapOvr>
+</p:sld>
+</file>
+
+<file path=ppt/slides/slide10.xml><?xml version="1.0" encoding="utf-8"?>
+<p:sld xmlns:a="http://schemas.openxmlformats.org/drawingml/2006/main" xmlns:p="http://schemas.openxmlformats.org/presentationml/2006/main" xmlns:r="http://schemas.openxmlformats.org/officeDocument/2006/relationships">
+  <p:cSld>
+    <p:spTree>
+      <p:nvGrpSpPr>
+        <p:cNvPr id="1" name=""/>
+        <p:cNvGrpSpPr/>
+        <p:nvPr/>
+      </p:nvGrpSpPr>
+      <p:grpSpPr/>
+      <p:sp>
+        <p:nvSpPr>
+          <p:cNvPr id="2" name="Rectangle 1"/>
+          <p:cNvSpPr/>
+          <p:nvPr/>
+        </p:nvSpPr>
+        <p:spPr>
+          <a:xfrm>
+            <a:off x="0" y="0"/>
+            <a:ext cx="12191695" cy="6858000"/>
+          </a:xfrm>
+          <a:prstGeom prst="rect">
+            <a:avLst/>
+          </a:prstGeom>
+          <a:solidFill>
+            <a:srgbClr val="12151C"/>
+          </a:solidFill>
+          <a:ln>
+            <a:noFill/>
+          </a:ln>
+          <a:effectLst/>
+        </p:spPr>
+        <p:style>
+          <a:lnRef idx="1">
+            <a:schemeClr val="accent1"/>
+          </a:lnRef>
+          <a:fillRef idx="3">
+            <a:schemeClr val="accent1"/>
+          </a:fillRef>
+          <a:effectRef idx="2">
+            <a:schemeClr val="accent1"/>
+          </a:effectRef>
+          <a:fontRef idx="minor">
+            <a:schemeClr val="lt1"/>
+          </a:fontRef>
+        </p:style>
+        <p:txBody>
+          <a:bodyPr rtlCol="0" anchor="ctr"/>
+          <a:lstStyle/>
+          <a:p>
+            <a:pPr algn="ctr"/>
+          </a:p>
+        </p:txBody>
+      </p:sp>
+      <p:sp>
+        <p:nvSpPr>
+          <p:cNvPr id="3" name="TextBox 2"/>
+          <p:cNvSpPr txBox="1"/>
+          <p:nvPr/>
+        </p:nvSpPr>
+        <p:spPr>
+          <a:xfrm>
+            <a:off x="548640" y="320040"/>
+            <a:ext cx="11094415" cy="292608"/>
+          </a:xfrm>
+          <a:prstGeom prst="rect">
+            <a:avLst/>
+          </a:prstGeom>
+          <a:noFill/>
+        </p:spPr>
+        <p:txBody>
+          <a:bodyPr wrap="square" anchor="t">
+            <a:spAutoFit/>
+          </a:bodyPr>
+          <a:lstStyle/>
+          <a:p>
+            <a:pPr algn="l">
+              <a:lnSpc>
+                <a:spcPct val="100000"/>
+              </a:lnSpc>
+            </a:pPr>
+            <a:r>
+              <a:rPr sz="1200" b="1">
+                <a:solidFill>
+                  <a:srgbClr val="FFB454"/>
+                </a:solidFill>
+                <a:latin typeface="Noto Sans CJK KR"/>
+              </a:rPr>
+              <a:t>MAX GRANULARITY · NEW</a:t>
+            </a:r>
+          </a:p>
+        </p:txBody>
+      </p:sp>
+      <p:sp>
+        <p:nvSpPr>
+          <p:cNvPr id="4" name="TextBox 3"/>
+          <p:cNvSpPr txBox="1"/>
+          <p:nvPr/>
+        </p:nvSpPr>
+        <p:spPr>
+          <a:xfrm>
+            <a:off x="548640" y="566928"/>
+            <a:ext cx="11094415" cy="548640"/>
+          </a:xfrm>
+          <a:prstGeom prst="rect">
+            <a:avLst/>
+          </a:prstGeom>
+          <a:noFill/>
+        </p:spPr>
+        <p:txBody>
+          <a:bodyPr wrap="square" anchor="t">
+            <a:spAutoFit/>
+          </a:bodyPr>
+          <a:lstStyle/>
+          <a:p>
+            <a:pPr algn="l">
+              <a:lnSpc>
+                <a:spcPct val="100000"/>
+              </a:lnSpc>
+            </a:pPr>
+            <a:r>
+              <a:rPr sz="2200" b="1">
+                <a:solidFill>
+                  <a:srgbClr val="E8ECF4"/>
+                </a:solidFill>
+                <a:latin typeface="Noto Sans CJK KR"/>
+              </a:rPr>
+              <a:t>GS Mapping 루프 최대 세분화</a:t>
+            </a:r>
+          </a:p>
+        </p:txBody>
+      </p:sp>
+      <p:sp>
+        <p:nvSpPr>
+          <p:cNvPr id="5" name="Rectangle 4"/>
+          <p:cNvSpPr/>
+          <p:nvPr/>
+        </p:nvSpPr>
+        <p:spPr>
+          <a:xfrm>
+            <a:off x="548640" y="1078992"/>
+            <a:ext cx="11094415" cy="25400"/>
+          </a:xfrm>
+          <a:prstGeom prst="rect">
+            <a:avLst/>
+          </a:prstGeom>
+          <a:solidFill>
+            <a:srgbClr val="2A3242"/>
+          </a:solidFill>
+          <a:ln>
+            <a:noFill/>
+          </a:ln>
+          <a:effectLst/>
+        </p:spPr>
+        <p:style>
+          <a:lnRef idx="1">
+            <a:schemeClr val="accent1"/>
+          </a:lnRef>
+          <a:fillRef idx="3">
+            <a:schemeClr val="accent1"/>
+          </a:fillRef>
+          <a:effectRef idx="2">
+            <a:schemeClr val="accent1"/>
+          </a:effectRef>
+          <a:fontRef idx="minor">
+            <a:schemeClr val="lt1"/>
+          </a:fontRef>
+        </p:style>
+        <p:txBody>
+          <a:bodyPr rtlCol="0" anchor="ctr"/>
+          <a:lstStyle/>
+          <a:p>
+            <a:pPr algn="ctr"/>
+          </a:p>
+        </p:txBody>
+      </p:sp>
+      <p:pic>
+        <p:nvPicPr>
+          <p:cNvPr id="6" name="Picture 5" descr="fig_gsmapping_granular.png"/>
+          <p:cNvPicPr>
+            <a:picLocks noChangeAspect="1"/>
+          </p:cNvPicPr>
+          <p:nvPr/>
+        </p:nvPicPr>
+        <p:blipFill>
+          <a:blip r:embed="rId2"/>
+          <a:stretch>
+            <a:fillRect/>
+          </a:stretch>
+        </p:blipFill>
+        <p:spPr>
+          <a:xfrm>
+            <a:off x="1538227" y="1325880"/>
+            <a:ext cx="9115240" cy="4297680"/>
+          </a:xfrm>
+          <a:prstGeom prst="rect">
+            <a:avLst/>
+          </a:prstGeom>
+        </p:spPr>
+      </p:pic>
+      <p:sp>
+        <p:nvSpPr>
+          <p:cNvPr id="7" name="TextBox 6"/>
+          <p:cNvSpPr txBox="1"/>
+          <p:nvPr/>
+        </p:nvSpPr>
+        <p:spPr>
+          <a:xfrm>
+            <a:off x="548640" y="5760720"/>
+            <a:ext cx="11094415" cy="822960"/>
+          </a:xfrm>
+          <a:prstGeom prst="rect">
+            <a:avLst/>
+          </a:prstGeom>
+          <a:noFill/>
+        </p:spPr>
+        <p:txBody>
+          <a:bodyPr wrap="square" anchor="t">
+            <a:spAutoFit/>
+          </a:bodyPr>
+          <a:lstStyle/>
+          <a:p>
+            <a:pPr algn="l">
+              <a:lnSpc>
+                <a:spcPct val="100000"/>
+              </a:lnSpc>
+            </a:pPr>
+            <a:r>
+              <a:rPr sz="1200" b="0">
+                <a:solidFill>
+                  <a:srgbClr val="8B95AB"/>
+                </a:solidFill>
+                <a:latin typeface="Noto Sans CJK KR"/>
+              </a:rPr>
+              <a:t>process_track_data() 전체(camera 생성·add_next_kf·pose 업데이트)까지 계측 범위를 넓혀 12단계로 세분화. rasterize+backward+loss_compute가 여전히 81.4%로 지배적 — 부가작업(camera_init·add_next_kf 등)은 4.2%뿐. map() 내부에 12.0초(12.9%) 미계측이 새로 발견됨(isotropic loss 계산·viewpoint 샘플링 추정, 다음 계측 후보).</a:t>
             </a:r>
           </a:p>
         </p:txBody>
@@ -3430,7 +3679,7 @@
                 </a:solidFill>
                 <a:latin typeface="Noto Sans CJK KR"/>
               </a:rPr>
-              <a:t>세 가지 질문에 대한 답</a:t>
+              <a:t>세 가지 질문에 대한 답 (정정판)</a:t>
             </a:r>
           </a:p>
         </p:txBody>
@@ -3550,7 +3799,7 @@
                 </a:solidFill>
                 <a:latin typeface="Noto Sans CJK KR"/>
               </a:rPr>
-              <a:t>부분적으로만. VIGS 저자 공식 벤치마크(RTX 5090)에서도 tracking만은 39.83fps(여유)지만 tracking+mapping은 12.02fps로 여전히 목표(30fps) 미달. 27.0초 오버헤드 중 21.1초(순수 Python 루프·IPC)는 GPU 세대와 거의 무관하게 남을 가능성이 큼 — GPU 업그레이드는 필요조건이지 충분조건이 아니다.</a:t>
+              <a:t>부분적으로만. VIGS 저자 공식 벤치마크(RTX 5090)에서도 tracking만은 39.83fps(여유)지만 tracking+mapping은 12.02fps로 여전히 목표(30fps) 미달 — GPU 업그레이드는 mapping 병목을 혼자 해결 못 함. (구 버전에서 언급한 "21.1초 미계측 Python 오버헤드"는 아래 정정 참조 — 실체가 밝혀지고 해소됨.)</a:t>
             </a:r>
           </a:p>
         </p:txBody>
@@ -3626,7 +3875,7 @@
                 </a:solidFill>
                 <a:latin typeface="Noto Sans CJK KR"/>
               </a:rPr>
-              <a:t>거의 같다 — 89.6초 vs 90.5초. 어느 한쪽만 0으로 줄여도 나머지 하나가 이미 예산(65.1초)을 넘는다. 두 축을 동시에 줄여야만 실시간에 도달한다.</a:t>
+              <a:t>거의 같다 — 58.6초 vs 85.8초(둘 다 경합 없는 상태 기준). 어느 한쪽만 0으로 줄여도 나머지 하나가 이미 예산(65.1초)을 넘는다(gs_mapping 단독으로도 초과). 두 축을 동시에 줄여야만 실시간에 도달한다.</a:t>
             </a:r>
           </a:p>
         </p:txBody>
@@ -3683,7 +3932,7 @@
                 </a:solidFill>
                 <a:latin typeface="Noto Sans CJK KR"/>
               </a:rPr>
-              <a:t>27.0초 오버헤드의 정체는?</a:t>
+              <a:t>⚠ 정정: "27.0초 오버헤드"는 실은 버그였다</a:t>
             </a:r>
           </a:p>
           <a:p>
@@ -3702,7 +3951,7 @@
                 </a:solidFill>
                 <a:latin typeface="Noto Sans CJK KR"/>
               </a:rPr>
-              <a:t>model_loading 1.5초(1회성) + queue_get_wait 4.4초(리더 프로세스 IPC 대기) + 미계측 잔여 21.1초(pbar 문자열 포맷·이미지 텐서 복사·save_trajectory의 GPU→CPU 전송+파일 I/O로 추정 — 아직 세분 계측 안 함, exp53 신규 축 후보).</a:t>
+              <a:t>실제 계측(pbar/save_trajectory 추가)으로 확인해보니 Python 루프 자체는 0.14초뿐 — 대신 demo.py의 리더 프로세스가 time.sleep(20) 후 종료하는데 reader.join()이 타이밍 마커보다 먼저 실행되던 위치 버그를 발견. 수정 후 모든 "온라인 루프 총합"이 ~20초씩 낮아짐 (180.10→150.56초, 133.04→98.94초) — 아래 슬라이드부터 전부 정정된 수치.</a:t>
             </a:r>
           </a:p>
         </p:txBody>
@@ -3803,7 +4052,7 @@
                 </a:solidFill>
                 <a:latin typeface="Noto Sans CJK KR"/>
               </a:rPr>
-              <a:t>TIMELINE · SCENARIO A</a:t>
+              <a:t>⚠ CORRECTION</a:t>
             </a:r>
           </a:p>
         </p:txBody>
@@ -3842,7 +4091,7 @@
                 </a:solidFill>
                 <a:latin typeface="Noto Sans CJK KR"/>
               </a:rPr>
-              <a:t>순차 실행 — gs_parallel 없이 돌리면</a:t>
+              <a:t>타이밍 버그 발견·수정 — 모든 수치 재검증</a:t>
             </a:r>
           </a:p>
         </p:txBody>
@@ -3891,39 +4140,303 @@
           </a:p>
         </p:txBody>
       </p:sp>
-      <p:pic>
-        <p:nvPicPr>
-          <p:cNvPr id="6" name="Picture 5" descr="fig_timeline_serial.png"/>
-          <p:cNvPicPr>
-            <a:picLocks noChangeAspect="1"/>
-          </p:cNvPicPr>
-          <p:nvPr/>
-        </p:nvPicPr>
-        <p:blipFill>
-          <a:blip r:embed="rId2"/>
-          <a:stretch>
-            <a:fillRect/>
-          </a:stretch>
-        </p:blipFill>
-        <p:spPr>
-          <a:xfrm>
-            <a:off x="1861229" y="1371600"/>
-            <a:ext cx="8469235" cy="2743200"/>
+      <p:sp>
+        <p:nvSpPr>
+          <p:cNvPr id="6" name="Rounded Rectangle 5"/>
+          <p:cNvSpPr/>
+          <p:nvPr/>
+        </p:nvSpPr>
+        <p:spPr>
+          <a:xfrm>
+            <a:off x="548640" y="1463040"/>
+            <a:ext cx="1417320" cy="292608"/>
+          </a:xfrm>
+          <a:prstGeom prst="roundRect">
+            <a:avLst>
+              <a:gd name="adj" fmla="val 50000"/>
+            </a:avLst>
+          </a:prstGeom>
+          <a:solidFill>
+            <a:srgbClr val="1A1F2B"/>
+          </a:solidFill>
+          <a:ln w="12700">
+            <a:solidFill>
+              <a:srgbClr val="FFB454"/>
+            </a:solidFill>
+          </a:ln>
+          <a:effectLst/>
+        </p:spPr>
+        <p:style>
+          <a:lnRef idx="1">
+            <a:schemeClr val="accent1"/>
+          </a:lnRef>
+          <a:fillRef idx="3">
+            <a:schemeClr val="accent1"/>
+          </a:fillRef>
+          <a:effectRef idx="2">
+            <a:schemeClr val="accent1"/>
+          </a:effectRef>
+          <a:fontRef idx="minor">
+            <a:schemeClr val="lt1"/>
+          </a:fontRef>
+        </p:style>
+        <p:txBody>
+          <a:bodyPr rtlCol="0" anchor="ctr" lIns="45720" rIns="45720"/>
+          <a:lstStyle/>
+          <a:p>
+            <a:pPr algn="ctr"/>
+            <a:r>
+              <a:rPr sz="950" b="1">
+                <a:solidFill>
+                  <a:srgbClr val="FFB454"/>
+                </a:solidFill>
+                <a:latin typeface="Noto Sans CJK KR"/>
+              </a:rPr>
+              <a:t>원인</a:t>
+            </a:r>
+          </a:p>
+        </p:txBody>
+      </p:sp>
+      <p:sp>
+        <p:nvSpPr>
+          <p:cNvPr id="7" name="TextBox 6"/>
+          <p:cNvSpPr txBox="1"/>
+          <p:nvPr/>
+        </p:nvSpPr>
+        <p:spPr>
+          <a:xfrm>
+            <a:off x="2148840" y="1435608"/>
+            <a:ext cx="9494215" cy="457200"/>
           </a:xfrm>
           <a:prstGeom prst="rect">
             <a:avLst/>
           </a:prstGeom>
-        </p:spPr>
-      </p:pic>
-      <p:sp>
-        <p:nvSpPr>
-          <p:cNvPr id="7" name="Rounded Rectangle 6"/>
+          <a:noFill/>
+        </p:spPr>
+        <p:txBody>
+          <a:bodyPr wrap="square" anchor="ctr">
+            <a:spAutoFit/>
+          </a:bodyPr>
+          <a:lstStyle/>
+          <a:p>
+            <a:pPr algn="l">
+              <a:lnSpc>
+                <a:spcPct val="100000"/>
+              </a:lnSpc>
+            </a:pPr>
+            <a:r>
+              <a:rPr sz="1250" b="0">
+                <a:solidFill>
+                  <a:srgbClr val="E8ECF4"/>
+                </a:solidFill>
+                <a:latin typeface="Noto Sans CJK KR"/>
+              </a:rPr>
+              <a:t>demo.py 리더 서브프로세스(mono_stream)가 마지막 프레임 큐잉 후 time.sleep(20) → 종료. reader.join()이 TRACK_LOOP_DONE_EPOCH 마커 출력보다 먼저 실행되어 이 인위적 20초가 모든 "온라인 루프 총합"에 섞여 있었음.</a:t>
+            </a:r>
+          </a:p>
+        </p:txBody>
+      </p:sp>
+      <p:sp>
+        <p:nvSpPr>
+          <p:cNvPr id="8" name="Rounded Rectangle 7"/>
           <p:cNvSpPr/>
           <p:nvPr/>
         </p:nvSpPr>
         <p:spPr>
           <a:xfrm>
-            <a:off x="548640" y="4343400"/>
+            <a:off x="548640" y="2240280"/>
+            <a:ext cx="1417320" cy="292608"/>
+          </a:xfrm>
+          <a:prstGeom prst="roundRect">
+            <a:avLst>
+              <a:gd name="adj" fmla="val 50000"/>
+            </a:avLst>
+          </a:prstGeom>
+          <a:solidFill>
+            <a:srgbClr val="1A1F2B"/>
+          </a:solidFill>
+          <a:ln w="12700">
+            <a:solidFill>
+              <a:srgbClr val="4C86EA"/>
+            </a:solidFill>
+          </a:ln>
+          <a:effectLst/>
+        </p:spPr>
+        <p:style>
+          <a:lnRef idx="1">
+            <a:schemeClr val="accent1"/>
+          </a:lnRef>
+          <a:fillRef idx="3">
+            <a:schemeClr val="accent1"/>
+          </a:fillRef>
+          <a:effectRef idx="2">
+            <a:schemeClr val="accent1"/>
+          </a:effectRef>
+          <a:fontRef idx="minor">
+            <a:schemeClr val="lt1"/>
+          </a:fontRef>
+        </p:style>
+        <p:txBody>
+          <a:bodyPr rtlCol="0" anchor="ctr" lIns="45720" rIns="45720"/>
+          <a:lstStyle/>
+          <a:p>
+            <a:pPr algn="ctr"/>
+            <a:r>
+              <a:rPr sz="950" b="1">
+                <a:solidFill>
+                  <a:srgbClr val="4C86EA"/>
+                </a:solidFill>
+                <a:latin typeface="Noto Sans CJK KR"/>
+              </a:rPr>
+              <a:t>영향 없음</a:t>
+            </a:r>
+          </a:p>
+        </p:txBody>
+      </p:sp>
+      <p:sp>
+        <p:nvSpPr>
+          <p:cNvPr id="9" name="TextBox 8"/>
+          <p:cNvSpPr txBox="1"/>
+          <p:nvPr/>
+        </p:nvSpPr>
+        <p:spPr>
+          <a:xfrm>
+            <a:off x="2148840" y="2212848"/>
+            <a:ext cx="9494215" cy="457200"/>
+          </a:xfrm>
+          <a:prstGeom prst="rect">
+            <a:avLst/>
+          </a:prstGeom>
+          <a:noFill/>
+        </p:spPr>
+        <p:txBody>
+          <a:bodyPr wrap="square" anchor="ctr">
+            <a:spAutoFit/>
+          </a:bodyPr>
+          <a:lstStyle/>
+          <a:p>
+            <a:pPr algn="l">
+              <a:lnSpc>
+                <a:spcPct val="100000"/>
+              </a:lnSpc>
+            </a:pPr>
+            <a:r>
+              <a:rPr sz="1250" b="0">
+                <a:solidFill>
+                  <a:srgbClr val="E8ECF4"/>
+                </a:solidFill>
+                <a:latin typeface="Noto Sans CJK KR"/>
+              </a:rPr>
+              <a:t>motion_filter/frontend/PGBA/gs_mapping 등 개별 구성요소 수치, fps 스윕(ORB vs VIGS), evo 궤적 정확도 비교 — 전부 다른 방식(vigs_track_total 태그 직접 합산)으로 측정해 이 버그와 무관.</a:t>
+            </a:r>
+          </a:p>
+        </p:txBody>
+      </p:sp>
+      <p:sp>
+        <p:nvSpPr>
+          <p:cNvPr id="10" name="Rounded Rectangle 9"/>
+          <p:cNvSpPr/>
+          <p:nvPr/>
+        </p:nvSpPr>
+        <p:spPr>
+          <a:xfrm>
+            <a:off x="548640" y="3017520"/>
+            <a:ext cx="1417320" cy="292608"/>
+          </a:xfrm>
+          <a:prstGeom prst="roundRect">
+            <a:avLst>
+              <a:gd name="adj" fmla="val 50000"/>
+            </a:avLst>
+          </a:prstGeom>
+          <a:solidFill>
+            <a:srgbClr val="1A1F2B"/>
+          </a:solidFill>
+          <a:ln w="12700">
+            <a:solidFill>
+              <a:srgbClr val="EF6A5C"/>
+            </a:solidFill>
+          </a:ln>
+          <a:effectLst/>
+        </p:spPr>
+        <p:style>
+          <a:lnRef idx="1">
+            <a:schemeClr val="accent1"/>
+          </a:lnRef>
+          <a:fillRef idx="3">
+            <a:schemeClr val="accent1"/>
+          </a:fillRef>
+          <a:effectRef idx="2">
+            <a:schemeClr val="accent1"/>
+          </a:effectRef>
+          <a:fontRef idx="minor">
+            <a:schemeClr val="lt1"/>
+          </a:fontRef>
+        </p:style>
+        <p:txBody>
+          <a:bodyPr rtlCol="0" anchor="ctr" lIns="45720" rIns="45720"/>
+          <a:lstStyle/>
+          <a:p>
+            <a:pPr algn="ctr"/>
+            <a:r>
+              <a:rPr sz="950" b="1">
+                <a:solidFill>
+                  <a:srgbClr val="EF6A5C"/>
+                </a:solidFill>
+                <a:latin typeface="Noto Sans CJK KR"/>
+              </a:rPr>
+              <a:t>수정</a:t>
+            </a:r>
+          </a:p>
+        </p:txBody>
+      </p:sp>
+      <p:sp>
+        <p:nvSpPr>
+          <p:cNvPr id="11" name="TextBox 10"/>
+          <p:cNvSpPr txBox="1"/>
+          <p:nvPr/>
+        </p:nvSpPr>
+        <p:spPr>
+          <a:xfrm>
+            <a:off x="2148840" y="2990088"/>
+            <a:ext cx="9494215" cy="457200"/>
+          </a:xfrm>
+          <a:prstGeom prst="rect">
+            <a:avLst/>
+          </a:prstGeom>
+          <a:noFill/>
+        </p:spPr>
+        <p:txBody>
+          <a:bodyPr wrap="square" anchor="ctr">
+            <a:spAutoFit/>
+          </a:bodyPr>
+          <a:lstStyle/>
+          <a:p>
+            <a:pPr algn="l">
+              <a:lnSpc>
+                <a:spcPct val="100000"/>
+              </a:lnSpc>
+            </a:pPr>
+            <a:r>
+              <a:rPr sz="1250" b="0">
+                <a:solidFill>
+                  <a:srgbClr val="E8ECF4"/>
+                </a:solidFill>
+                <a:latin typeface="Noto Sans CJK KR"/>
+              </a:rPr>
+              <a:t>타이밍 마커 출력을 reader.join()보다 앞으로 이동(demo.py). 리더 프로세스 정리는 순수 teardown이지 측정 대상 워크로드가 아님.</a:t>
+            </a:r>
+          </a:p>
+        </p:txBody>
+      </p:sp>
+      <p:sp>
+        <p:nvSpPr>
+          <p:cNvPr id="12" name="Rounded Rectangle 11"/>
+          <p:cNvSpPr/>
+          <p:nvPr/>
+        </p:nvSpPr>
+        <p:spPr>
+          <a:xfrm>
+            <a:off x="548640" y="3977639"/>
             <a:ext cx="3566160" cy="1051560"/>
           </a:xfrm>
           <a:prstGeom prst="roundRect">
@@ -3967,7 +4480,7 @@
                 </a:solidFill>
                 <a:latin typeface="Noto Sans CJK KR"/>
               </a:rPr>
-              <a:t>180.10s</a:t>
+              <a:t>180.10→150.56s</a:t>
             </a:r>
           </a:p>
           <a:p>
@@ -3979,20 +4492,20 @@
                 </a:solidFill>
                 <a:latin typeface="Noto Sans CJK KR"/>
               </a:rPr>
-              <a:t>총합</a:t>
-            </a:r>
-          </a:p>
-        </p:txBody>
-      </p:sp>
-      <p:sp>
-        <p:nvSpPr>
-          <p:cNvPr id="8" name="Rounded Rectangle 7"/>
+              <a:t>순차: 기존→정정</a:t>
+            </a:r>
+          </a:p>
+        </p:txBody>
+      </p:sp>
+      <p:sp>
+        <p:nvSpPr>
+          <p:cNvPr id="13" name="Rounded Rectangle 12"/>
           <p:cNvSpPr/>
           <p:nvPr/>
         </p:nvSpPr>
         <p:spPr>
           <a:xfrm>
-            <a:off x="4297679" y="4343400"/>
+            <a:off x="4297679" y="3977639"/>
             <a:ext cx="3566160" cy="1051560"/>
           </a:xfrm>
           <a:prstGeom prst="roundRect">
@@ -4005,7 +4518,7 @@
           </a:solidFill>
           <a:ln w="15875">
             <a:solidFill>
-              <a:srgbClr val="FFB454"/>
+              <a:srgbClr val="E8ECF4"/>
             </a:solidFill>
           </a:ln>
           <a:effectLst/>
@@ -4032,11 +4545,11 @@
             <a:r>
               <a:rPr sz="2200" b="1">
                 <a:solidFill>
-                  <a:srgbClr val="FFB454"/>
+                  <a:srgbClr val="E8ECF4"/>
                 </a:solidFill>
                 <a:latin typeface="Noto Sans CJK KR"/>
               </a:rPr>
-              <a:t>2.77×</a:t>
+              <a:t>133.04→98.94s</a:t>
             </a:r>
           </a:p>
           <a:p>
@@ -4048,20 +4561,20 @@
                 </a:solidFill>
                 <a:latin typeface="Noto Sans CJK KR"/>
               </a:rPr>
-              <a:t>실시간 배수</a:t>
-            </a:r>
-          </a:p>
-        </p:txBody>
-      </p:sp>
-      <p:sp>
-        <p:nvSpPr>
-          <p:cNvPr id="9" name="Rounded Rectangle 8"/>
+              <a:t>병렬: 기존→정정</a:t>
+            </a:r>
+          </a:p>
+        </p:txBody>
+      </p:sp>
+      <p:sp>
+        <p:nvSpPr>
+          <p:cNvPr id="14" name="Rounded Rectangle 13"/>
           <p:cNvSpPr/>
           <p:nvPr/>
         </p:nvSpPr>
         <p:spPr>
           <a:xfrm>
-            <a:off x="8046719" y="4343400"/>
+            <a:off x="8046719" y="3977639"/>
             <a:ext cx="3657600" cy="1051560"/>
           </a:xfrm>
           <a:prstGeom prst="roundRect">
@@ -4074,7 +4587,7 @@
           </a:solidFill>
           <a:ln w="15875">
             <a:solidFill>
-              <a:srgbClr val="EF6A5C"/>
+              <a:srgbClr val="4C86EA"/>
             </a:solidFill>
           </a:ln>
           <a:effectLst/>
@@ -4101,11 +4614,11 @@
             <a:r>
               <a:rPr sz="2200" b="1">
                 <a:solidFill>
-                  <a:srgbClr val="EF6A5C"/>
+                  <a:srgbClr val="4C86EA"/>
                 </a:solidFill>
                 <a:latin typeface="Noto Sans CJK KR"/>
               </a:rPr>
-              <a:t>50.2%</a:t>
+              <a:t>21.1s→0.2s</a:t>
             </a:r>
           </a:p>
           <a:p>
@@ -4117,20 +4630,20 @@
                 </a:solidFill>
                 <a:latin typeface="Noto Sans CJK KR"/>
               </a:rPr>
-              <a:t>gs_mapping 비중</a:t>
-            </a:r>
-          </a:p>
-        </p:txBody>
-      </p:sp>
-      <p:sp>
-        <p:nvSpPr>
-          <p:cNvPr id="10" name="TextBox 9"/>
+              <a:t>미계측 잔여</a:t>
+            </a:r>
+          </a:p>
+        </p:txBody>
+      </p:sp>
+      <p:sp>
+        <p:nvSpPr>
+          <p:cNvPr id="15" name="TextBox 14"/>
           <p:cNvSpPr txBox="1"/>
           <p:nvPr/>
         </p:nvSpPr>
         <p:spPr>
           <a:xfrm>
-            <a:off x="548640" y="5623560"/>
+            <a:off x="548640" y="5212080"/>
             <a:ext cx="11094415" cy="822960"/>
           </a:xfrm>
           <a:prstGeom prst="rect">
@@ -4150,13 +4663,13 @@
               </a:lnSpc>
             </a:pPr>
             <a:r>
-              <a:rPr sz="1200" b="0">
+              <a:rPr sz="1250" b="0">
                 <a:solidFill>
                   <a:srgbClr val="8B95AB"/>
                 </a:solidFill>
                 <a:latin typeface="Noto Sans CJK KR"/>
               </a:rPr>
-              <a:t>한 프레임당 motion_filter→frontend→PGBA→gs_mapping이 전부 같은 스레드에서 순서대로 실행된다고 가정했을 때, 전체 시퀀스에 걸쳐 각 단계가 누적한 시간의 구성.</a:t>
+              <a:t>실시간 대비 배수도 재계산: 순차 2.77배→2.31배, gs_parallel 2.04배→1.52배 — 이전 생각보다 실시간 격차가 훨씬 작다. 결론 방향은 안 바뀜(①gs_mapping 연산량 감소 최우선 ②frontend는 경합 대응이 핵심 ③오버헤드는 이제 해결됨), exp53이 메꿔야 할 목표만 작아짐.</a:t>
             </a:r>
           </a:p>
         </p:txBody>
@@ -4257,7 +4770,7 @@
                 </a:solidFill>
                 <a:latin typeface="Noto Sans CJK KR"/>
               </a:rPr>
-              <a:t>TIMELINE · SCENARIO B</a:t>
+              <a:t>TIMELINE · SCENARIO A</a:t>
             </a:r>
           </a:p>
         </p:txBody>
@@ -4296,7 +4809,7 @@
                 </a:solidFill>
                 <a:latin typeface="Noto Sans CJK KR"/>
               </a:rPr>
-              <a:t>gs_parallel — 두 스레드가 GPU를 나눠 쓰면</a:t>
+              <a:t>순차 실행 — gs_parallel 없이 돌리면 (정정판)</a:t>
             </a:r>
           </a:p>
         </p:txBody>
@@ -4347,7 +4860,7 @@
       </p:sp>
       <p:pic>
         <p:nvPicPr>
-          <p:cNvPr id="6" name="Picture 5" descr="fig_timeline_parallel.png"/>
+          <p:cNvPr id="6" name="Picture 5" descr="fig_timeline_serial.png"/>
           <p:cNvPicPr>
             <a:picLocks noChangeAspect="1"/>
           </p:cNvPicPr>
@@ -4361,8 +4874,8 @@
         </p:blipFill>
         <p:spPr>
           <a:xfrm>
-            <a:off x="2207462" y="1371600"/>
-            <a:ext cx="7776770" cy="3017520"/>
+            <a:off x="1873841" y="1371600"/>
+            <a:ext cx="8444011" cy="2743200"/>
           </a:xfrm>
           <a:prstGeom prst="rect">
             <a:avLst/>
@@ -4377,7 +4890,7 @@
         </p:nvSpPr>
         <p:spPr>
           <a:xfrm>
-            <a:off x="548640" y="4617720"/>
+            <a:off x="548640" y="4343400"/>
             <a:ext cx="3566160" cy="1051560"/>
           </a:xfrm>
           <a:prstGeom prst="roundRect">
@@ -4421,7 +4934,7 @@
                 </a:solidFill>
                 <a:latin typeface="Noto Sans CJK KR"/>
               </a:rPr>
-              <a:t>133.04s</a:t>
+              <a:t>150.56s</a:t>
             </a:r>
           </a:p>
           <a:p>
@@ -4433,7 +4946,7 @@
                 </a:solidFill>
                 <a:latin typeface="Noto Sans CJK KR"/>
               </a:rPr>
-              <a:t>총합(실측)</a:t>
+              <a:t>총합</a:t>
             </a:r>
           </a:p>
         </p:txBody>
@@ -4446,7 +4959,7 @@
         </p:nvSpPr>
         <p:spPr>
           <a:xfrm>
-            <a:off x="4297679" y="4617720"/>
+            <a:off x="4297679" y="4343400"/>
             <a:ext cx="3566160" cy="1051560"/>
           </a:xfrm>
           <a:prstGeom prst="roundRect">
@@ -4490,7 +5003,7 @@
                 </a:solidFill>
                 <a:latin typeface="Noto Sans CJK KR"/>
               </a:rPr>
-              <a:t>2.04×</a:t>
+              <a:t>2.31×</a:t>
             </a:r>
           </a:p>
           <a:p>
@@ -4515,7 +5028,7 @@
         </p:nvSpPr>
         <p:spPr>
           <a:xfrm>
-            <a:off x="8046719" y="4617720"/>
+            <a:off x="8046719" y="4343400"/>
             <a:ext cx="3657600" cy="1051560"/>
           </a:xfrm>
           <a:prstGeom prst="roundRect">
@@ -4528,7 +5041,7 @@
           </a:solidFill>
           <a:ln w="15875">
             <a:solidFill>
-              <a:srgbClr val="4C86EA"/>
+              <a:srgbClr val="EF6A5C"/>
             </a:solidFill>
           </a:ln>
           <a:effectLst/>
@@ -4555,11 +5068,11 @@
             <a:r>
               <a:rPr sz="2200" b="1">
                 <a:solidFill>
-                  <a:srgbClr val="4C86EA"/>
+                  <a:srgbClr val="EF6A5C"/>
                 </a:solidFill>
                 <a:latin typeface="Noto Sans CJK KR"/>
               </a:rPr>
-              <a:t>−26.1%</a:t>
+              <a:t>57.0%</a:t>
             </a:r>
           </a:p>
           <a:p>
@@ -4571,7 +5084,7 @@
                 </a:solidFill>
                 <a:latin typeface="Noto Sans CJK KR"/>
               </a:rPr>
-              <a:t>순차 대비</a:t>
+              <a:t>gs_mapping 비중</a:t>
             </a:r>
           </a:p>
         </p:txBody>
@@ -4584,8 +5097,8 @@
         </p:nvSpPr>
         <p:spPr>
           <a:xfrm>
-            <a:off x="548640" y="5852160"/>
-            <a:ext cx="11094415" cy="640080"/>
+            <a:off x="548640" y="5623560"/>
+            <a:ext cx="11094415" cy="822960"/>
           </a:xfrm>
           <a:prstGeom prst="rect">
             <a:avLst/>
@@ -4610,7 +5123,7 @@
                 </a:solidFill>
                 <a:latin typeface="Noto Sans CJK KR"/>
               </a:rPr>
-              <a:t>두 스레드 다 133.04초에 함께 끝난다 — 한쪽이 먼저 끝나고 기다리는 구조가 아니라, 서로가 서로를 GPU 경합으로 늦추며 같은 시점에 수렴한다.</a:t>
+              <a:t>한 프레임당 motion_filter→frontend→PGBA→gs_mapping이 전부 같은 스레드에서 순서대로 실행된다고 가정했을 때, 전체 시퀀스에 걸쳐 각 단계가 누적한 시간의 구성. 오버헤드는 6.0초로 축소(리더 프로세스 타이밍 버그 수정 후).</a:t>
             </a:r>
           </a:p>
         </p:txBody>
@@ -4711,7 +5224,7 @@
                 </a:solidFill>
                 <a:latin typeface="Noto Sans CJK KR"/>
               </a:rPr>
-              <a:t>CONTENTION IS BIDIRECTIONAL</a:t>
+              <a:t>TIMELINE · SCENARIO B</a:t>
             </a:r>
           </a:p>
         </p:txBody>
@@ -4750,7 +5263,7 @@
                 </a:solidFill>
                 <a:latin typeface="Noto Sans CJK KR"/>
               </a:rPr>
-              <a:t>왜 frontend가 병렬일 때 오히려 느려지나</a:t>
+              <a:t>gs_parallel — 두 스레드가 GPU를 나눠 쓰면 (정정판)</a:t>
             </a:r>
           </a:p>
         </p:txBody>
@@ -4801,7 +5314,7 @@
       </p:sp>
       <p:pic>
         <p:nvPicPr>
-          <p:cNvPr id="6" name="Picture 5" descr="fig_frontend_contention.png"/>
+          <p:cNvPr id="6" name="Picture 5" descr="fig_timeline_parallel.png"/>
           <p:cNvPicPr>
             <a:picLocks noChangeAspect="1"/>
           </p:cNvPicPr>
@@ -4815,8 +5328,8 @@
         </p:blipFill>
         <p:spPr>
           <a:xfrm>
-            <a:off x="2172342" y="1371600"/>
-            <a:ext cx="7847009" cy="3063240"/>
+            <a:off x="2315627" y="1371600"/>
+            <a:ext cx="7560440" cy="3017520"/>
           </a:xfrm>
           <a:prstGeom prst="rect">
             <a:avLst/>
@@ -4825,14 +5338,221 @@
       </p:pic>
       <p:sp>
         <p:nvSpPr>
-          <p:cNvPr id="7" name="TextBox 6"/>
+          <p:cNvPr id="7" name="Rounded Rectangle 6"/>
+          <p:cNvSpPr/>
+          <p:nvPr/>
+        </p:nvSpPr>
+        <p:spPr>
+          <a:xfrm>
+            <a:off x="548640" y="4617720"/>
+            <a:ext cx="3566160" cy="1051560"/>
+          </a:xfrm>
+          <a:prstGeom prst="roundRect">
+            <a:avLst>
+              <a:gd name="adj" fmla="val 8000"/>
+            </a:avLst>
+          </a:prstGeom>
+          <a:solidFill>
+            <a:srgbClr val="1A1F2B"/>
+          </a:solidFill>
+          <a:ln w="15875">
+            <a:solidFill>
+              <a:srgbClr val="E8ECF4"/>
+            </a:solidFill>
+          </a:ln>
+          <a:effectLst/>
+        </p:spPr>
+        <p:style>
+          <a:lnRef idx="1">
+            <a:schemeClr val="accent1"/>
+          </a:lnRef>
+          <a:fillRef idx="3">
+            <a:schemeClr val="accent1"/>
+          </a:fillRef>
+          <a:effectRef idx="2">
+            <a:schemeClr val="accent1"/>
+          </a:effectRef>
+          <a:fontRef idx="minor">
+            <a:schemeClr val="lt1"/>
+          </a:fontRef>
+        </p:style>
+        <p:txBody>
+          <a:bodyPr rtlCol="0" anchor="ctr" wrap="square" lIns="146304" rIns="146304"/>
+          <a:lstStyle/>
+          <a:p>
+            <a:pPr algn="ctr"/>
+            <a:r>
+              <a:rPr sz="2200" b="1">
+                <a:solidFill>
+                  <a:srgbClr val="E8ECF4"/>
+                </a:solidFill>
+                <a:latin typeface="Noto Sans CJK KR"/>
+              </a:rPr>
+              <a:t>98.94s</a:t>
+            </a:r>
+          </a:p>
+          <a:p>
+            <a:pPr algn="ctr"/>
+            <a:r>
+              <a:rPr sz="1050">
+                <a:solidFill>
+                  <a:srgbClr val="8B95AB"/>
+                </a:solidFill>
+                <a:latin typeface="Noto Sans CJK KR"/>
+              </a:rPr>
+              <a:t>총합(실측)</a:t>
+            </a:r>
+          </a:p>
+        </p:txBody>
+      </p:sp>
+      <p:sp>
+        <p:nvSpPr>
+          <p:cNvPr id="8" name="Rounded Rectangle 7"/>
+          <p:cNvSpPr/>
+          <p:nvPr/>
+        </p:nvSpPr>
+        <p:spPr>
+          <a:xfrm>
+            <a:off x="4297679" y="4617720"/>
+            <a:ext cx="3566160" cy="1051560"/>
+          </a:xfrm>
+          <a:prstGeom prst="roundRect">
+            <a:avLst>
+              <a:gd name="adj" fmla="val 8000"/>
+            </a:avLst>
+          </a:prstGeom>
+          <a:solidFill>
+            <a:srgbClr val="1A1F2B"/>
+          </a:solidFill>
+          <a:ln w="15875">
+            <a:solidFill>
+              <a:srgbClr val="FFB454"/>
+            </a:solidFill>
+          </a:ln>
+          <a:effectLst/>
+        </p:spPr>
+        <p:style>
+          <a:lnRef idx="1">
+            <a:schemeClr val="accent1"/>
+          </a:lnRef>
+          <a:fillRef idx="3">
+            <a:schemeClr val="accent1"/>
+          </a:fillRef>
+          <a:effectRef idx="2">
+            <a:schemeClr val="accent1"/>
+          </a:effectRef>
+          <a:fontRef idx="minor">
+            <a:schemeClr val="lt1"/>
+          </a:fontRef>
+        </p:style>
+        <p:txBody>
+          <a:bodyPr rtlCol="0" anchor="ctr" wrap="square" lIns="146304" rIns="146304"/>
+          <a:lstStyle/>
+          <a:p>
+            <a:pPr algn="ctr"/>
+            <a:r>
+              <a:rPr sz="2200" b="1">
+                <a:solidFill>
+                  <a:srgbClr val="FFB454"/>
+                </a:solidFill>
+                <a:latin typeface="Noto Sans CJK KR"/>
+              </a:rPr>
+              <a:t>1.52×</a:t>
+            </a:r>
+          </a:p>
+          <a:p>
+            <a:pPr algn="ctr"/>
+            <a:r>
+              <a:rPr sz="1050">
+                <a:solidFill>
+                  <a:srgbClr val="8B95AB"/>
+                </a:solidFill>
+                <a:latin typeface="Noto Sans CJK KR"/>
+              </a:rPr>
+              <a:t>실시간 배수</a:t>
+            </a:r>
+          </a:p>
+        </p:txBody>
+      </p:sp>
+      <p:sp>
+        <p:nvSpPr>
+          <p:cNvPr id="9" name="Rounded Rectangle 8"/>
+          <p:cNvSpPr/>
+          <p:nvPr/>
+        </p:nvSpPr>
+        <p:spPr>
+          <a:xfrm>
+            <a:off x="8046719" y="4617720"/>
+            <a:ext cx="3657600" cy="1051560"/>
+          </a:xfrm>
+          <a:prstGeom prst="roundRect">
+            <a:avLst>
+              <a:gd name="adj" fmla="val 8000"/>
+            </a:avLst>
+          </a:prstGeom>
+          <a:solidFill>
+            <a:srgbClr val="1A1F2B"/>
+          </a:solidFill>
+          <a:ln w="15875">
+            <a:solidFill>
+              <a:srgbClr val="4C86EA"/>
+            </a:solidFill>
+          </a:ln>
+          <a:effectLst/>
+        </p:spPr>
+        <p:style>
+          <a:lnRef idx="1">
+            <a:schemeClr val="accent1"/>
+          </a:lnRef>
+          <a:fillRef idx="3">
+            <a:schemeClr val="accent1"/>
+          </a:fillRef>
+          <a:effectRef idx="2">
+            <a:schemeClr val="accent1"/>
+          </a:effectRef>
+          <a:fontRef idx="minor">
+            <a:schemeClr val="lt1"/>
+          </a:fontRef>
+        </p:style>
+        <p:txBody>
+          <a:bodyPr rtlCol="0" anchor="ctr" wrap="square" lIns="146304" rIns="146304"/>
+          <a:lstStyle/>
+          <a:p>
+            <a:pPr algn="ctr"/>
+            <a:r>
+              <a:rPr sz="2200" b="1">
+                <a:solidFill>
+                  <a:srgbClr val="4C86EA"/>
+                </a:solidFill>
+                <a:latin typeface="Noto Sans CJK KR"/>
+              </a:rPr>
+              <a:t>−34.3%</a:t>
+            </a:r>
+          </a:p>
+          <a:p>
+            <a:pPr algn="ctr"/>
+            <a:r>
+              <a:rPr sz="1050">
+                <a:solidFill>
+                  <a:srgbClr val="8B95AB"/>
+                </a:solidFill>
+                <a:latin typeface="Noto Sans CJK KR"/>
+              </a:rPr>
+              <a:t>순차 대비</a:t>
+            </a:r>
+          </a:p>
+        </p:txBody>
+      </p:sp>
+      <p:sp>
+        <p:nvSpPr>
+          <p:cNvPr id="10" name="TextBox 9"/>
           <p:cNvSpPr txBox="1"/>
           <p:nvPr/>
         </p:nvSpPr>
         <p:spPr>
           <a:xfrm>
-            <a:off x="548640" y="4617720"/>
-            <a:ext cx="11094415" cy="777240"/>
+            <a:off x="548640" y="5852160"/>
+            <a:ext cx="11094415" cy="640080"/>
           </a:xfrm>
           <a:prstGeom prst="rect">
             <a:avLst/>
@@ -4851,52 +5571,13 @@
               </a:lnSpc>
             </a:pPr>
             <a:r>
-              <a:rPr sz="1250" b="0">
-                <a:solidFill>
-                  <a:srgbClr val="E8ECF4"/>
+              <a:rPr sz="1200" b="0">
+                <a:solidFill>
+                  <a:srgbClr val="8B95AB"/>
                 </a:solidFill>
                 <a:latin typeface="Noto Sans CJK KR"/>
               </a:rPr>
-              <a:t>GPU 경합은 매핑 쪽에만 일어나는 게 아니라 양방향이다 — bundle_adjust(BA solve)와 update_op_forward(GRU)는 frontend에서 가장 무거운 GPU 커널인데, rasterize/backward처럼 gs_mapping이 던지는 무거운 커널과 같은 SM·메모리 대역폭을 놓고 경쟁한다.</a:t>
-            </a:r>
-          </a:p>
-        </p:txBody>
-      </p:sp>
-      <p:sp>
-        <p:nvSpPr>
-          <p:cNvPr id="8" name="TextBox 7"/>
-          <p:cNvSpPr txBox="1"/>
-          <p:nvPr/>
-        </p:nvSpPr>
-        <p:spPr>
-          <a:xfrm>
-            <a:off x="548640" y="5349240"/>
-            <a:ext cx="11094415" cy="777240"/>
-          </a:xfrm>
-          <a:prstGeom prst="rect">
-            <a:avLst/>
-          </a:prstGeom>
-          <a:noFill/>
-        </p:spPr>
-        <p:txBody>
-          <a:bodyPr wrap="square" anchor="t">
-            <a:spAutoFit/>
-          </a:bodyPr>
-          <a:lstStyle/>
-          <a:p>
-            <a:pPr algn="l">
-              <a:lnSpc>
-                <a:spcPct val="100000"/>
-              </a:lnSpc>
-            </a:pPr>
-            <a:r>
-              <a:rPr sz="1250" b="0">
-                <a:solidFill>
-                  <a:srgbClr val="8B95AB"/>
-                </a:solidFill>
-                <a:latin typeface="Noto Sans CJK KR"/>
-              </a:rPr>
-              <a:t>반면 PGBA(pgba_run)는 sparse pose graph 최적화라 상대적으로 가벼워 거의 안 느려짐(+12%) — mapping 자체도 거의 그대로(90.5→86.24s). 가설(미검증, nsys 트레이스 필요): mapping이 던지는 크고 지속시간 긴 커널 뒤에서 frontend의 작고 빈번한 커널들이 줄서서 기다린다.</a:t>
+              <a:t>두 스레드 다 98.94초에 함께 끝난다 — 한쪽이 먼저 끝나고 기다리는 구조가 아니라, 서로가 서로를 GPU 경합으로 늦추며 같은 시점에 수렴한다.</a:t>
             </a:r>
           </a:p>
         </p:txBody>
@@ -4997,7 +5678,7 @@
                 </a:solidFill>
                 <a:latin typeface="Noto Sans CJK KR"/>
               </a:rPr>
-              <a:t>HOW PARALLEL, EXACTLY</a:t>
+              <a:t>CONTENTION IS BIDIRECTIONAL</a:t>
             </a:r>
           </a:p>
         </p:txBody>
@@ -5036,7 +5717,7 @@
                 </a:solidFill>
                 <a:latin typeface="Noto Sans CJK KR"/>
               </a:rPr>
-              <a:t>오버랩 효율 — 실제로 얼마나 겹치는가</a:t>
+              <a:t>왜 frontend가 병렬일 때 오히려 느려지나 (정정판)</a:t>
             </a:r>
           </a:p>
         </p:txBody>
@@ -5087,7 +5768,7 @@
       </p:sp>
       <p:pic>
         <p:nvPicPr>
-          <p:cNvPr id="6" name="Picture 5" descr="fig_overlap_efficiency.png"/>
+          <p:cNvPr id="6" name="Picture 5" descr="fig_frontend_contention.png"/>
           <p:cNvPicPr>
             <a:picLocks noChangeAspect="1"/>
           </p:cNvPicPr>
@@ -5101,8 +5782,8 @@
         </p:blipFill>
         <p:spPr>
           <a:xfrm>
-            <a:off x="2054001" y="1280160"/>
-            <a:ext cx="8083692" cy="3794760"/>
+            <a:off x="2285688" y="1371600"/>
+            <a:ext cx="7620318" cy="3063240"/>
           </a:xfrm>
           <a:prstGeom prst="rect">
             <a:avLst/>
@@ -5111,221 +5792,14 @@
       </p:pic>
       <p:sp>
         <p:nvSpPr>
-          <p:cNvPr id="7" name="Rounded Rectangle 6"/>
-          <p:cNvSpPr/>
-          <p:nvPr/>
-        </p:nvSpPr>
-        <p:spPr>
-          <a:xfrm>
-            <a:off x="548640" y="5212080"/>
-            <a:ext cx="3566160" cy="960120"/>
-          </a:xfrm>
-          <a:prstGeom prst="roundRect">
-            <a:avLst>
-              <a:gd name="adj" fmla="val 8000"/>
-            </a:avLst>
-          </a:prstGeom>
-          <a:solidFill>
-            <a:srgbClr val="1A1F2B"/>
-          </a:solidFill>
-          <a:ln w="15875">
-            <a:solidFill>
-              <a:srgbClr val="4C86EA"/>
-            </a:solidFill>
-          </a:ln>
-          <a:effectLst/>
-        </p:spPr>
-        <p:style>
-          <a:lnRef idx="1">
-            <a:schemeClr val="accent1"/>
-          </a:lnRef>
-          <a:fillRef idx="3">
-            <a:schemeClr val="accent1"/>
-          </a:fillRef>
-          <a:effectRef idx="2">
-            <a:schemeClr val="accent1"/>
-          </a:effectRef>
-          <a:fontRef idx="minor">
-            <a:schemeClr val="lt1"/>
-          </a:fontRef>
-        </p:style>
-        <p:txBody>
-          <a:bodyPr rtlCol="0" anchor="ctr" wrap="square" lIns="146304" rIns="146304"/>
-          <a:lstStyle/>
-          <a:p>
-            <a:pPr algn="ctr"/>
-            <a:r>
-              <a:rPr sz="2200" b="1">
-                <a:solidFill>
-                  <a:srgbClr val="4C86EA"/>
-                </a:solidFill>
-                <a:latin typeface="Noto Sans CJK KR"/>
-              </a:rPr>
-              <a:t>66.0%</a:t>
-            </a:r>
-          </a:p>
-          <a:p>
-            <a:pPr algn="ctr"/>
-            <a:r>
-              <a:rPr sz="1050">
-                <a:solidFill>
-                  <a:srgbClr val="8B95AB"/>
-                </a:solidFill>
-                <a:latin typeface="Noto Sans CJK KR"/>
-              </a:rPr>
-              <a:t>오버랩 효율</a:t>
-            </a:r>
-          </a:p>
-        </p:txBody>
-      </p:sp>
-      <p:sp>
-        <p:nvSpPr>
-          <p:cNvPr id="8" name="Rounded Rectangle 7"/>
-          <p:cNvSpPr/>
-          <p:nvPr/>
-        </p:nvSpPr>
-        <p:spPr>
-          <a:xfrm>
-            <a:off x="4297679" y="5212080"/>
-            <a:ext cx="3566160" cy="960120"/>
-          </a:xfrm>
-          <a:prstGeom prst="roundRect">
-            <a:avLst>
-              <a:gd name="adj" fmla="val 8000"/>
-            </a:avLst>
-          </a:prstGeom>
-          <a:solidFill>
-            <a:srgbClr val="1A1F2B"/>
-          </a:solidFill>
-          <a:ln w="15875">
-            <a:solidFill>
-              <a:srgbClr val="EF6A5C"/>
-            </a:solidFill>
-          </a:ln>
-          <a:effectLst/>
-        </p:spPr>
-        <p:style>
-          <a:lnRef idx="1">
-            <a:schemeClr val="accent1"/>
-          </a:lnRef>
-          <a:fillRef idx="3">
-            <a:schemeClr val="accent1"/>
-          </a:fillRef>
-          <a:effectRef idx="2">
-            <a:schemeClr val="accent1"/>
-          </a:effectRef>
-          <a:fontRef idx="minor">
-            <a:schemeClr val="lt1"/>
-          </a:fontRef>
-        </p:style>
-        <p:txBody>
-          <a:bodyPr rtlCol="0" anchor="ctr" wrap="square" lIns="146304" rIns="146304"/>
-          <a:lstStyle/>
-          <a:p>
-            <a:pPr algn="ctr"/>
-            <a:r>
-              <a:rPr sz="2200" b="1">
-                <a:solidFill>
-                  <a:srgbClr val="EF6A5C"/>
-                </a:solidFill>
-                <a:latin typeface="Noto Sans CJK KR"/>
-              </a:rPr>
-              <a:t>34.0%</a:t>
-            </a:r>
-          </a:p>
-          <a:p>
-            <a:pPr algn="ctr"/>
-            <a:r>
-              <a:rPr sz="1050">
-                <a:solidFill>
-                  <a:srgbClr val="8B95AB"/>
-                </a:solidFill>
-                <a:latin typeface="Noto Sans CJK KR"/>
-              </a:rPr>
-              <a:t>GPU 경합으로 손실</a:t>
-            </a:r>
-          </a:p>
-        </p:txBody>
-      </p:sp>
-      <p:sp>
-        <p:nvSpPr>
-          <p:cNvPr id="9" name="Rounded Rectangle 8"/>
-          <p:cNvSpPr/>
-          <p:nvPr/>
-        </p:nvSpPr>
-        <p:spPr>
-          <a:xfrm>
-            <a:off x="8046719" y="5212080"/>
-            <a:ext cx="3657600" cy="960120"/>
-          </a:xfrm>
-          <a:prstGeom prst="roundRect">
-            <a:avLst>
-              <a:gd name="adj" fmla="val 8000"/>
-            </a:avLst>
-          </a:prstGeom>
-          <a:solidFill>
-            <a:srgbClr val="1A1F2B"/>
-          </a:solidFill>
-          <a:ln w="15875">
-            <a:solidFill>
-              <a:srgbClr val="8B95AB"/>
-            </a:solidFill>
-          </a:ln>
-          <a:effectLst/>
-        </p:spPr>
-        <p:style>
-          <a:lnRef idx="1">
-            <a:schemeClr val="accent1"/>
-          </a:lnRef>
-          <a:fillRef idx="3">
-            <a:schemeClr val="accent1"/>
-          </a:fillRef>
-          <a:effectRef idx="2">
-            <a:schemeClr val="accent1"/>
-          </a:effectRef>
-          <a:fontRef idx="minor">
-            <a:schemeClr val="lt1"/>
-          </a:fontRef>
-        </p:style>
-        <p:txBody>
-          <a:bodyPr rtlCol="0" anchor="ctr" wrap="square" lIns="146304" rIns="146304"/>
-          <a:lstStyle/>
-          <a:p>
-            <a:pPr algn="ctr"/>
-            <a:r>
-              <a:rPr sz="2200" b="1">
-                <a:solidFill>
-                  <a:srgbClr val="8B95AB"/>
-                </a:solidFill>
-                <a:latin typeface="Noto Sans CJK KR"/>
-              </a:rPr>
-              <a:t>103.72s</a:t>
-            </a:r>
-          </a:p>
-          <a:p>
-            <a:pPr algn="ctr"/>
-            <a:r>
-              <a:rPr sz="1050">
-                <a:solidFill>
-                  <a:srgbClr val="8B95AB"/>
-                </a:solidFill>
-                <a:latin typeface="Noto Sans CJK KR"/>
-              </a:rPr>
-              <a:t>Tracking 실측(같은 런)</a:t>
-            </a:r>
-          </a:p>
-        </p:txBody>
-      </p:sp>
-      <p:sp>
-        <p:nvSpPr>
-          <p:cNvPr id="10" name="TextBox 9"/>
+          <p:cNvPr id="7" name="TextBox 6"/>
           <p:cNvSpPr txBox="1"/>
           <p:nvPr/>
         </p:nvSpPr>
         <p:spPr>
           <a:xfrm>
-            <a:off x="548640" y="6309360"/>
-            <a:ext cx="11094415" cy="457200"/>
+            <a:off x="548640" y="4617720"/>
+            <a:ext cx="11094415" cy="777240"/>
           </a:xfrm>
           <a:prstGeom prst="rect">
             <a:avLst/>
@@ -5344,13 +5818,52 @@
               </a:lnSpc>
             </a:pPr>
             <a:r>
-              <a:rPr sz="1050" b="0">
-                <a:solidFill>
-                  <a:srgbClr val="8B95AB"/>
+              <a:rPr sz="1250" b="0">
+                <a:solidFill>
+                  <a:srgbClr val="E8ECF4"/>
                 </a:solidFill>
                 <a:latin typeface="Noto Sans CJK KR"/>
               </a:rPr>
-              <a:t>※ 103.72s는 "경합이 없었을 때의 tracking 비용"이 아니라 이 gs_parallel 런에서 실측된 값 — 그 자체로 이미 위 슬라이드의 경합을 포함하고 있다.</a:t>
+              <a:t>GPU 경합은 매핑 쪽에만 일어나는 게 아니라 양방향이다 — bundle_adjust(BA solve)와 update_op_forward(GRU)는 frontend에서 가장 무거운 GPU 커널인데, rasterize/backward처럼 gs_mapping이 던지는 무거운 커널과 같은 SM·메모리 대역폭을 놓고 경쟁한다.</a:t>
+            </a:r>
+          </a:p>
+        </p:txBody>
+      </p:sp>
+      <p:sp>
+        <p:nvSpPr>
+          <p:cNvPr id="8" name="TextBox 7"/>
+          <p:cNvSpPr txBox="1"/>
+          <p:nvPr/>
+        </p:nvSpPr>
+        <p:spPr>
+          <a:xfrm>
+            <a:off x="548640" y="5349240"/>
+            <a:ext cx="11094415" cy="777240"/>
+          </a:xfrm>
+          <a:prstGeom prst="rect">
+            <a:avLst/>
+          </a:prstGeom>
+          <a:noFill/>
+        </p:spPr>
+        <p:txBody>
+          <a:bodyPr wrap="square" anchor="t">
+            <a:spAutoFit/>
+          </a:bodyPr>
+          <a:lstStyle/>
+          <a:p>
+            <a:pPr algn="l">
+              <a:lnSpc>
+                <a:spcPct val="100000"/>
+              </a:lnSpc>
+            </a:pPr>
+            <a:r>
+              <a:rPr sz="1250" b="0">
+                <a:solidFill>
+                  <a:srgbClr val="8B95AB"/>
+                </a:solidFill>
+                <a:latin typeface="Noto Sans CJK KR"/>
+              </a:rPr>
+              <a:t>반면 PGBA(pgba_run)는 sparse pose graph 최적화라 상대적으로 가벼워 거의 안 느려짐(+12%) — mapping 자체도 거의 그대로. 가설(미검증, nsys 트레이스 필요): mapping이 던지는 크고 지속시간 긴 커널 뒤에서 frontend의 작고 빈번한 커널들이 줄서서 기다린다.</a:t>
             </a:r>
           </a:p>
         </p:txBody>
@@ -5451,7 +5964,7 @@
                 </a:solidFill>
                 <a:latin typeface="Noto Sans CJK KR"/>
               </a:rPr>
-              <a:t>THE FLOOR</a:t>
+              <a:t>HOW PARALLEL, EXACTLY</a:t>
             </a:r>
           </a:p>
         </p:txBody>
@@ -5490,7 +6003,7 @@
                 </a:solidFill>
                 <a:latin typeface="Noto Sans CJK KR"/>
               </a:rPr>
-              <a:t>완벽한 병렬화를 가정해도 안 되는 이유</a:t>
+              <a:t>오버랩 효율 — 실제로 얼마나 겹치는가 (정정판)</a:t>
             </a:r>
           </a:p>
         </p:txBody>
@@ -5541,7 +6054,7 @@
       </p:sp>
       <p:pic>
         <p:nvPicPr>
-          <p:cNvPr id="6" name="Picture 5" descr="fig_theoretical_floor.png"/>
+          <p:cNvPr id="6" name="Picture 5" descr="fig_overlap_efficiency.png"/>
           <p:cNvPicPr>
             <a:picLocks noChangeAspect="1"/>
           </p:cNvPicPr>
@@ -5555,8 +6068,8 @@
         </p:blipFill>
         <p:spPr>
           <a:xfrm>
-            <a:off x="2755747" y="1325880"/>
-            <a:ext cx="6680200" cy="1965960"/>
+            <a:off x="2078404" y="1280160"/>
+            <a:ext cx="8034885" cy="3794760"/>
           </a:xfrm>
           <a:prstGeom prst="rect">
             <a:avLst/>
@@ -5565,14 +6078,221 @@
       </p:pic>
       <p:sp>
         <p:nvSpPr>
-          <p:cNvPr id="7" name="TextBox 6"/>
+          <p:cNvPr id="7" name="Rounded Rectangle 6"/>
+          <p:cNvSpPr/>
+          <p:nvPr/>
+        </p:nvSpPr>
+        <p:spPr>
+          <a:xfrm>
+            <a:off x="548640" y="5212080"/>
+            <a:ext cx="3566160" cy="960120"/>
+          </a:xfrm>
+          <a:prstGeom prst="roundRect">
+            <a:avLst>
+              <a:gd name="adj" fmla="val 8000"/>
+            </a:avLst>
+          </a:prstGeom>
+          <a:solidFill>
+            <a:srgbClr val="1A1F2B"/>
+          </a:solidFill>
+          <a:ln w="15875">
+            <a:solidFill>
+              <a:srgbClr val="4C86EA"/>
+            </a:solidFill>
+          </a:ln>
+          <a:effectLst/>
+        </p:spPr>
+        <p:style>
+          <a:lnRef idx="1">
+            <a:schemeClr val="accent1"/>
+          </a:lnRef>
+          <a:fillRef idx="3">
+            <a:schemeClr val="accent1"/>
+          </a:fillRef>
+          <a:effectRef idx="2">
+            <a:schemeClr val="accent1"/>
+          </a:effectRef>
+          <a:fontRef idx="minor">
+            <a:schemeClr val="lt1"/>
+          </a:fontRef>
+        </p:style>
+        <p:txBody>
+          <a:bodyPr rtlCol="0" anchor="ctr" wrap="square" lIns="146304" rIns="146304"/>
+          <a:lstStyle/>
+          <a:p>
+            <a:pPr algn="ctr"/>
+            <a:r>
+              <a:rPr sz="2200" b="1">
+                <a:solidFill>
+                  <a:srgbClr val="4C86EA"/>
+                </a:solidFill>
+                <a:latin typeface="Noto Sans CJK KR"/>
+              </a:rPr>
+              <a:t>88.3%</a:t>
+            </a:r>
+          </a:p>
+          <a:p>
+            <a:pPr algn="ctr"/>
+            <a:r>
+              <a:rPr sz="1050">
+                <a:solidFill>
+                  <a:srgbClr val="8B95AB"/>
+                </a:solidFill>
+                <a:latin typeface="Noto Sans CJK KR"/>
+              </a:rPr>
+              <a:t>오버랩 효율</a:t>
+            </a:r>
+          </a:p>
+        </p:txBody>
+      </p:sp>
+      <p:sp>
+        <p:nvSpPr>
+          <p:cNvPr id="8" name="Rounded Rectangle 7"/>
+          <p:cNvSpPr/>
+          <p:nvPr/>
+        </p:nvSpPr>
+        <p:spPr>
+          <a:xfrm>
+            <a:off x="4297679" y="5212080"/>
+            <a:ext cx="3566160" cy="960120"/>
+          </a:xfrm>
+          <a:prstGeom prst="roundRect">
+            <a:avLst>
+              <a:gd name="adj" fmla="val 8000"/>
+            </a:avLst>
+          </a:prstGeom>
+          <a:solidFill>
+            <a:srgbClr val="1A1F2B"/>
+          </a:solidFill>
+          <a:ln w="15875">
+            <a:solidFill>
+              <a:srgbClr val="EF6A5C"/>
+            </a:solidFill>
+          </a:ln>
+          <a:effectLst/>
+        </p:spPr>
+        <p:style>
+          <a:lnRef idx="1">
+            <a:schemeClr val="accent1"/>
+          </a:lnRef>
+          <a:fillRef idx="3">
+            <a:schemeClr val="accent1"/>
+          </a:fillRef>
+          <a:effectRef idx="2">
+            <a:schemeClr val="accent1"/>
+          </a:effectRef>
+          <a:fontRef idx="minor">
+            <a:schemeClr val="lt1"/>
+          </a:fontRef>
+        </p:style>
+        <p:txBody>
+          <a:bodyPr rtlCol="0" anchor="ctr" wrap="square" lIns="146304" rIns="146304"/>
+          <a:lstStyle/>
+          <a:p>
+            <a:pPr algn="ctr"/>
+            <a:r>
+              <a:rPr sz="2200" b="1">
+                <a:solidFill>
+                  <a:srgbClr val="EF6A5C"/>
+                </a:solidFill>
+                <a:latin typeface="Noto Sans CJK KR"/>
+              </a:rPr>
+              <a:t>11.7%</a:t>
+            </a:r>
+          </a:p>
+          <a:p>
+            <a:pPr algn="ctr"/>
+            <a:r>
+              <a:rPr sz="1050">
+                <a:solidFill>
+                  <a:srgbClr val="8B95AB"/>
+                </a:solidFill>
+                <a:latin typeface="Noto Sans CJK KR"/>
+              </a:rPr>
+              <a:t>GPU 경합으로 손실</a:t>
+            </a:r>
+          </a:p>
+        </p:txBody>
+      </p:sp>
+      <p:sp>
+        <p:nvSpPr>
+          <p:cNvPr id="9" name="Rounded Rectangle 8"/>
+          <p:cNvSpPr/>
+          <p:nvPr/>
+        </p:nvSpPr>
+        <p:spPr>
+          <a:xfrm>
+            <a:off x="8046719" y="5212080"/>
+            <a:ext cx="3657600" cy="960120"/>
+          </a:xfrm>
+          <a:prstGeom prst="roundRect">
+            <a:avLst>
+              <a:gd name="adj" fmla="val 8000"/>
+            </a:avLst>
+          </a:prstGeom>
+          <a:solidFill>
+            <a:srgbClr val="1A1F2B"/>
+          </a:solidFill>
+          <a:ln w="15875">
+            <a:solidFill>
+              <a:srgbClr val="8B95AB"/>
+            </a:solidFill>
+          </a:ln>
+          <a:effectLst/>
+        </p:spPr>
+        <p:style>
+          <a:lnRef idx="1">
+            <a:schemeClr val="accent1"/>
+          </a:lnRef>
+          <a:fillRef idx="3">
+            <a:schemeClr val="accent1"/>
+          </a:fillRef>
+          <a:effectRef idx="2">
+            <a:schemeClr val="accent1"/>
+          </a:effectRef>
+          <a:fontRef idx="minor">
+            <a:schemeClr val="lt1"/>
+          </a:fontRef>
+        </p:style>
+        <p:txBody>
+          <a:bodyPr rtlCol="0" anchor="ctr" wrap="square" lIns="146304" rIns="146304"/>
+          <a:lstStyle/>
+          <a:p>
+            <a:pPr algn="ctr"/>
+            <a:r>
+              <a:rPr sz="2200" b="1">
+                <a:solidFill>
+                  <a:srgbClr val="8B95AB"/>
+                </a:solidFill>
+                <a:latin typeface="Noto Sans CJK KR"/>
+              </a:rPr>
+              <a:t>89.99s</a:t>
+            </a:r>
+          </a:p>
+          <a:p>
+            <a:pPr algn="ctr"/>
+            <a:r>
+              <a:rPr sz="1050">
+                <a:solidFill>
+                  <a:srgbClr val="8B95AB"/>
+                </a:solidFill>
+                <a:latin typeface="Noto Sans CJK KR"/>
+              </a:rPr>
+              <a:t>Tracking 실측(같은 런)</a:t>
+            </a:r>
+          </a:p>
+        </p:txBody>
+      </p:sp>
+      <p:sp>
+        <p:nvSpPr>
+          <p:cNvPr id="10" name="TextBox 9"/>
           <p:cNvSpPr txBox="1"/>
           <p:nvPr/>
         </p:nvSpPr>
         <p:spPr>
           <a:xfrm>
-            <a:off x="548640" y="3429000"/>
-            <a:ext cx="11094415" cy="502920"/>
+            <a:off x="548640" y="6309360"/>
+            <a:ext cx="11094415" cy="457200"/>
           </a:xfrm>
           <a:prstGeom prst="rect">
             <a:avLst/>
@@ -5591,493 +6311,13 @@
               </a:lnSpc>
             </a:pPr>
             <a:r>
-              <a:rPr sz="1350" b="1">
-                <a:solidFill>
-                  <a:srgbClr val="E8ECF4"/>
+              <a:rPr sz="1050" b="0">
+                <a:solidFill>
+                  <a:srgbClr val="8B95AB"/>
                 </a:solidFill>
                 <a:latin typeface="Noto Sans CJK KR"/>
               </a:rPr>
-              <a:t>병렬화(exp52)만으로는 구조적으로 도달 불가 — 직렬 체인과 gs_mapping을 각각 65.1초 아래로 줄여야 한다.</a:t>
-            </a:r>
-          </a:p>
-        </p:txBody>
-      </p:sp>
-      <p:sp>
-        <p:nvSpPr>
-          <p:cNvPr id="8" name="Rounded Rectangle 7"/>
-          <p:cNvSpPr/>
-          <p:nvPr/>
-        </p:nvSpPr>
-        <p:spPr>
-          <a:xfrm>
-            <a:off x="548640" y="3794760"/>
-            <a:ext cx="1417320" cy="292608"/>
-          </a:xfrm>
-          <a:prstGeom prst="roundRect">
-            <a:avLst>
-              <a:gd name="adj" fmla="val 50000"/>
-            </a:avLst>
-          </a:prstGeom>
-          <a:solidFill>
-            <a:srgbClr val="1A1F2B"/>
-          </a:solidFill>
-          <a:ln w="12700">
-            <a:solidFill>
-              <a:srgbClr val="FFB454"/>
-            </a:solidFill>
-          </a:ln>
-          <a:effectLst/>
-        </p:spPr>
-        <p:style>
-          <a:lnRef idx="1">
-            <a:schemeClr val="accent1"/>
-          </a:lnRef>
-          <a:fillRef idx="3">
-            <a:schemeClr val="accent1"/>
-          </a:fillRef>
-          <a:effectRef idx="2">
-            <a:schemeClr val="accent1"/>
-          </a:effectRef>
-          <a:fontRef idx="minor">
-            <a:schemeClr val="lt1"/>
-          </a:fontRef>
-        </p:style>
-        <p:txBody>
-          <a:bodyPr rtlCol="0" anchor="ctr" lIns="45720" rIns="45720"/>
-          <a:lstStyle/>
-          <a:p>
-            <a:pPr algn="ctr"/>
-            <a:r>
-              <a:rPr sz="950" b="1">
-                <a:solidFill>
-                  <a:srgbClr val="FFB454"/>
-                </a:solidFill>
-                <a:latin typeface="Noto Sans CJK KR"/>
-              </a:rPr>
-              <a:t>EXP53 · 최우선</a:t>
-            </a:r>
-          </a:p>
-        </p:txBody>
-      </p:sp>
-      <p:sp>
-        <p:nvSpPr>
-          <p:cNvPr id="9" name="TextBox 8"/>
-          <p:cNvSpPr txBox="1"/>
-          <p:nvPr/>
-        </p:nvSpPr>
-        <p:spPr>
-          <a:xfrm>
-            <a:off x="2148840" y="3767328"/>
-            <a:ext cx="9494215" cy="457200"/>
-          </a:xfrm>
-          <a:prstGeom prst="rect">
-            <a:avLst/>
-          </a:prstGeom>
-          <a:noFill/>
-        </p:spPr>
-        <p:txBody>
-          <a:bodyPr wrap="square" anchor="ctr">
-            <a:spAutoFit/>
-          </a:bodyPr>
-          <a:lstStyle/>
-          <a:p>
-            <a:pPr algn="l">
-              <a:lnSpc>
-                <a:spcPct val="100000"/>
-              </a:lnSpc>
-            </a:pPr>
-            <a:r>
-              <a:rPr sz="1250" b="0">
-                <a:solidFill>
-                  <a:srgbClr val="E8ECF4"/>
-                </a:solidFill>
-                <a:latin typeface="Noto Sans CJK KR"/>
-              </a:rPr>
-              <a:t>Frontend 반복 축소(iters1/iters2) — bundle_adjust+update_op_forward가 frontend 43.2s의 80%. 직렬 체인을 줄이는 가장 직접적인 레버.</a:t>
-            </a:r>
-          </a:p>
-        </p:txBody>
-      </p:sp>
-      <p:sp>
-        <p:nvSpPr>
-          <p:cNvPr id="10" name="Rounded Rectangle 9"/>
-          <p:cNvSpPr/>
-          <p:nvPr/>
-        </p:nvSpPr>
-        <p:spPr>
-          <a:xfrm>
-            <a:off x="548640" y="4325112"/>
-            <a:ext cx="1417320" cy="292608"/>
-          </a:xfrm>
-          <a:prstGeom prst="roundRect">
-            <a:avLst>
-              <a:gd name="adj" fmla="val 50000"/>
-            </a:avLst>
-          </a:prstGeom>
-          <a:solidFill>
-            <a:srgbClr val="1A1F2B"/>
-          </a:solidFill>
-          <a:ln w="12700">
-            <a:solidFill>
-              <a:srgbClr val="4C86EA"/>
-            </a:solidFill>
-          </a:ln>
-          <a:effectLst/>
-        </p:spPr>
-        <p:style>
-          <a:lnRef idx="1">
-            <a:schemeClr val="accent1"/>
-          </a:lnRef>
-          <a:fillRef idx="3">
-            <a:schemeClr val="accent1"/>
-          </a:fillRef>
-          <a:effectRef idx="2">
-            <a:schemeClr val="accent1"/>
-          </a:effectRef>
-          <a:fontRef idx="minor">
-            <a:schemeClr val="lt1"/>
-          </a:fontRef>
-        </p:style>
-        <p:txBody>
-          <a:bodyPr rtlCol="0" anchor="ctr" lIns="45720" rIns="45720"/>
-          <a:lstStyle/>
-          <a:p>
-            <a:pPr algn="ctr"/>
-            <a:r>
-              <a:rPr sz="950" b="1">
-                <a:solidFill>
-                  <a:srgbClr val="4C86EA"/>
-                </a:solidFill>
-                <a:latin typeface="Noto Sans CJK KR"/>
-              </a:rPr>
-              <a:t>EXP53</a:t>
-            </a:r>
-          </a:p>
-        </p:txBody>
-      </p:sp>
-      <p:sp>
-        <p:nvSpPr>
-          <p:cNvPr id="11" name="TextBox 10"/>
-          <p:cNvSpPr txBox="1"/>
-          <p:nvPr/>
-        </p:nvSpPr>
-        <p:spPr>
-          <a:xfrm>
-            <a:off x="2148840" y="4297680"/>
-            <a:ext cx="9494215" cy="457200"/>
-          </a:xfrm>
-          <a:prstGeom prst="rect">
-            <a:avLst/>
-          </a:prstGeom>
-          <a:noFill/>
-        </p:spPr>
-        <p:txBody>
-          <a:bodyPr wrap="square" anchor="ctr">
-            <a:spAutoFit/>
-          </a:bodyPr>
-          <a:lstStyle/>
-          <a:p>
-            <a:pPr algn="l">
-              <a:lnSpc>
-                <a:spcPct val="100000"/>
-              </a:lnSpc>
-            </a:pPr>
-            <a:r>
-              <a:rPr sz="1250" b="0">
-                <a:solidFill>
-                  <a:srgbClr val="E8ECF4"/>
-                </a:solidFill>
-                <a:latin typeface="Noto Sans CJK KR"/>
-              </a:rPr>
-              <a:t>keyframe 밀도 억제(motion_filter.thresh) — keyframe 발생이 fps와 무관하다는 게 확인됐으니, 밀도 자체를 낮추는 게 fps를 낮추는 것보다 유효.</a:t>
-            </a:r>
-          </a:p>
-        </p:txBody>
-      </p:sp>
-      <p:sp>
-        <p:nvSpPr>
-          <p:cNvPr id="12" name="Rounded Rectangle 11"/>
-          <p:cNvSpPr/>
-          <p:nvPr/>
-        </p:nvSpPr>
-        <p:spPr>
-          <a:xfrm>
-            <a:off x="548640" y="4855464"/>
-            <a:ext cx="1417320" cy="292608"/>
-          </a:xfrm>
-          <a:prstGeom prst="roundRect">
-            <a:avLst>
-              <a:gd name="adj" fmla="val 50000"/>
-            </a:avLst>
-          </a:prstGeom>
-          <a:solidFill>
-            <a:srgbClr val="1A1F2B"/>
-          </a:solidFill>
-          <a:ln w="12700">
-            <a:solidFill>
-              <a:srgbClr val="EF6A5C"/>
-            </a:solidFill>
-          </a:ln>
-          <a:effectLst/>
-        </p:spPr>
-        <p:style>
-          <a:lnRef idx="1">
-            <a:schemeClr val="accent1"/>
-          </a:lnRef>
-          <a:fillRef idx="3">
-            <a:schemeClr val="accent1"/>
-          </a:fillRef>
-          <a:effectRef idx="2">
-            <a:schemeClr val="accent1"/>
-          </a:effectRef>
-          <a:fontRef idx="minor">
-            <a:schemeClr val="lt1"/>
-          </a:fontRef>
-        </p:style>
-        <p:txBody>
-          <a:bodyPr rtlCol="0" anchor="ctr" lIns="45720" rIns="45720"/>
-          <a:lstStyle/>
-          <a:p>
-            <a:pPr algn="ctr"/>
-            <a:r>
-              <a:rPr sz="950" b="1">
-                <a:solidFill>
-                  <a:srgbClr val="EF6A5C"/>
-                </a:solidFill>
-                <a:latin typeface="Noto Sans CJK KR"/>
-              </a:rPr>
-              <a:t>EXP53 · 신규</a:t>
-            </a:r>
-          </a:p>
-        </p:txBody>
-      </p:sp>
-      <p:sp>
-        <p:nvSpPr>
-          <p:cNvPr id="13" name="TextBox 12"/>
-          <p:cNvSpPr txBox="1"/>
-          <p:nvPr/>
-        </p:nvSpPr>
-        <p:spPr>
-          <a:xfrm>
-            <a:off x="2148840" y="4828032"/>
-            <a:ext cx="9494215" cy="457200"/>
-          </a:xfrm>
-          <a:prstGeom prst="rect">
-            <a:avLst/>
-          </a:prstGeom>
-          <a:noFill/>
-        </p:spPr>
-        <p:txBody>
-          <a:bodyPr wrap="square" anchor="ctr">
-            <a:spAutoFit/>
-          </a:bodyPr>
-          <a:lstStyle/>
-          <a:p>
-            <a:pPr algn="l">
-              <a:lnSpc>
-                <a:spcPct val="100000"/>
-              </a:lnSpc>
-            </a:pPr>
-            <a:r>
-              <a:rPr sz="1250" b="0">
-                <a:solidFill>
-                  <a:srgbClr val="E8ECF4"/>
-                </a:solidFill>
-                <a:latin typeface="Noto Sans CJK KR"/>
-              </a:rPr>
-              <a:t>27.0초 오버헤드 세분 계측 — 21.1초 미계측 잔여의 정체 파악. GPU와 무관하게 남을 항목이라 별도 대응 필요.</a:t>
-            </a:r>
-          </a:p>
-        </p:txBody>
-      </p:sp>
-      <p:sp>
-        <p:nvSpPr>
-          <p:cNvPr id="14" name="Rounded Rectangle 13"/>
-          <p:cNvSpPr/>
-          <p:nvPr/>
-        </p:nvSpPr>
-        <p:spPr>
-          <a:xfrm>
-            <a:off x="548640" y="5385816"/>
-            <a:ext cx="1417320" cy="292608"/>
-          </a:xfrm>
-          <a:prstGeom prst="roundRect">
-            <a:avLst>
-              <a:gd name="adj" fmla="val 50000"/>
-            </a:avLst>
-          </a:prstGeom>
-          <a:solidFill>
-            <a:srgbClr val="1A1F2B"/>
-          </a:solidFill>
-          <a:ln w="12700">
-            <a:solidFill>
-              <a:srgbClr val="E8ECF4"/>
-            </a:solidFill>
-          </a:ln>
-          <a:effectLst/>
-        </p:spPr>
-        <p:style>
-          <a:lnRef idx="1">
-            <a:schemeClr val="accent1"/>
-          </a:lnRef>
-          <a:fillRef idx="3">
-            <a:schemeClr val="accent1"/>
-          </a:fillRef>
-          <a:effectRef idx="2">
-            <a:schemeClr val="accent1"/>
-          </a:effectRef>
-          <a:fontRef idx="minor">
-            <a:schemeClr val="lt1"/>
-          </a:fontRef>
-        </p:style>
-        <p:txBody>
-          <a:bodyPr rtlCol="0" anchor="ctr" lIns="45720" rIns="45720"/>
-          <a:lstStyle/>
-          <a:p>
-            <a:pPr algn="ctr"/>
-            <a:r>
-              <a:rPr sz="950" b="1">
-                <a:solidFill>
-                  <a:srgbClr val="E8ECF4"/>
-                </a:solidFill>
-                <a:latin typeface="Noto Sans CJK KR"/>
-              </a:rPr>
-              <a:t>EXP53 · 신규</a:t>
-            </a:r>
-          </a:p>
-        </p:txBody>
-      </p:sp>
-      <p:sp>
-        <p:nvSpPr>
-          <p:cNvPr id="15" name="TextBox 14"/>
-          <p:cNvSpPr txBox="1"/>
-          <p:nvPr/>
-        </p:nvSpPr>
-        <p:spPr>
-          <a:xfrm>
-            <a:off x="2148840" y="5358384"/>
-            <a:ext cx="9494215" cy="457200"/>
-          </a:xfrm>
-          <a:prstGeom prst="rect">
-            <a:avLst/>
-          </a:prstGeom>
-          <a:noFill/>
-        </p:spPr>
-        <p:txBody>
-          <a:bodyPr wrap="square" anchor="ctr">
-            <a:spAutoFit/>
-          </a:bodyPr>
-          <a:lstStyle/>
-          <a:p>
-            <a:pPr algn="l">
-              <a:lnSpc>
-                <a:spcPct val="100000"/>
-              </a:lnSpc>
-            </a:pPr>
-            <a:r>
-              <a:rPr sz="1250" b="0">
-                <a:solidFill>
-                  <a:srgbClr val="E8ECF4"/>
-                </a:solidFill>
-                <a:latin typeface="Noto Sans CJK KR"/>
-              </a:rPr>
-              <a:t>축A~D를 gs_parallel 켠 상태/끈 상태 둘 다에서 측정 — frontend가 경합 시 +72% 느려짐이 확인됐으니, 순차 측정만으론 병렬 실전 효과를 과대추정할 수 있음.</a:t>
-            </a:r>
-          </a:p>
-        </p:txBody>
-      </p:sp>
-      <p:sp>
-        <p:nvSpPr>
-          <p:cNvPr id="16" name="Rounded Rectangle 15"/>
-          <p:cNvSpPr/>
-          <p:nvPr/>
-        </p:nvSpPr>
-        <p:spPr>
-          <a:xfrm>
-            <a:off x="548640" y="5916168"/>
-            <a:ext cx="1417320" cy="292608"/>
-          </a:xfrm>
-          <a:prstGeom prst="roundRect">
-            <a:avLst>
-              <a:gd name="adj" fmla="val 50000"/>
-            </a:avLst>
-          </a:prstGeom>
-          <a:solidFill>
-            <a:srgbClr val="1A1F2B"/>
-          </a:solidFill>
-          <a:ln w="12700">
-            <a:solidFill>
-              <a:srgbClr val="8B95AB"/>
-            </a:solidFill>
-          </a:ln>
-          <a:effectLst/>
-        </p:spPr>
-        <p:style>
-          <a:lnRef idx="1">
-            <a:schemeClr val="accent1"/>
-          </a:lnRef>
-          <a:fillRef idx="3">
-            <a:schemeClr val="accent1"/>
-          </a:fillRef>
-          <a:effectRef idx="2">
-            <a:schemeClr val="accent1"/>
-          </a:effectRef>
-          <a:fontRef idx="minor">
-            <a:schemeClr val="lt1"/>
-          </a:fontRef>
-        </p:style>
-        <p:txBody>
-          <a:bodyPr rtlCol="0" anchor="ctr" lIns="45720" rIns="45720"/>
-          <a:lstStyle/>
-          <a:p>
-            <a:pPr algn="ctr"/>
-            <a:r>
-              <a:rPr sz="950" b="1">
-                <a:solidFill>
-                  <a:srgbClr val="8B95AB"/>
-                </a:solidFill>
-                <a:latin typeface="Noto Sans CJK KR"/>
-              </a:rPr>
-              <a:t>EXP52 · 계속</a:t>
-            </a:r>
-          </a:p>
-        </p:txBody>
-      </p:sp>
-      <p:sp>
-        <p:nvSpPr>
-          <p:cNvPr id="17" name="TextBox 16"/>
-          <p:cNvSpPr txBox="1"/>
-          <p:nvPr/>
-        </p:nvSpPr>
-        <p:spPr>
-          <a:xfrm>
-            <a:off x="2148840" y="5888736"/>
-            <a:ext cx="9494215" cy="457200"/>
-          </a:xfrm>
-          <a:prstGeom prst="rect">
-            <a:avLst/>
-          </a:prstGeom>
-          <a:noFill/>
-        </p:spPr>
-        <p:txBody>
-          <a:bodyPr wrap="square" anchor="ctr">
-            <a:spAutoFit/>
-          </a:bodyPr>
-          <a:lstStyle/>
-          <a:p>
-            <a:pPr algn="l">
-              <a:lnSpc>
-                <a:spcPct val="100000"/>
-              </a:lnSpc>
-            </a:pPr>
-            <a:r>
-              <a:rPr sz="1250" b="0">
-                <a:solidFill>
-                  <a:srgbClr val="E8ECF4"/>
-                </a:solidFill>
-                <a:latin typeface="Noto Sans CJK KR"/>
-              </a:rPr>
-              <a:t>gs_mapping 자체 연산량 감소 — iteration 수·해상도·densify 빈도. RTX 5090에서도 저자 자신이 12.02fps(미달)였던 부분이라 GPU 업그레이드만으론 부족.</a:t>
+              <a:t>※ 89.99s는 "경합이 없었을 때의 tracking 비용"이 아니라 이 gs_parallel 런에서 실측된 값 — 그 자체로 이미 위 슬라이드의 경합을 포함하고 있다.</a:t>
             </a:r>
           </a:p>
         </p:txBody>
@@ -6178,7 +6418,7 @@
                 </a:solidFill>
                 <a:latin typeface="Noto Sans CJK KR"/>
               </a:rPr>
-              <a:t>COMPONENT BREAKDOWN</a:t>
+              <a:t>THE FLOOR</a:t>
             </a:r>
           </a:p>
         </p:txBody>
@@ -6217,7 +6457,734 @@
                 </a:solidFill>
                 <a:latin typeface="Noto Sans CJK KR"/>
               </a:rPr>
-              <a:t>구성요소별 세부 분해</a:t>
+              <a:t>완벽한 병렬화를 가정해도 안 되는 이유 (정정판)</a:t>
+            </a:r>
+          </a:p>
+        </p:txBody>
+      </p:sp>
+      <p:sp>
+        <p:nvSpPr>
+          <p:cNvPr id="5" name="Rectangle 4"/>
+          <p:cNvSpPr/>
+          <p:nvPr/>
+        </p:nvSpPr>
+        <p:spPr>
+          <a:xfrm>
+            <a:off x="548640" y="1078992"/>
+            <a:ext cx="11094415" cy="25400"/>
+          </a:xfrm>
+          <a:prstGeom prst="rect">
+            <a:avLst/>
+          </a:prstGeom>
+          <a:solidFill>
+            <a:srgbClr val="2A3242"/>
+          </a:solidFill>
+          <a:ln>
+            <a:noFill/>
+          </a:ln>
+          <a:effectLst/>
+        </p:spPr>
+        <p:style>
+          <a:lnRef idx="1">
+            <a:schemeClr val="accent1"/>
+          </a:lnRef>
+          <a:fillRef idx="3">
+            <a:schemeClr val="accent1"/>
+          </a:fillRef>
+          <a:effectRef idx="2">
+            <a:schemeClr val="accent1"/>
+          </a:effectRef>
+          <a:fontRef idx="minor">
+            <a:schemeClr val="lt1"/>
+          </a:fontRef>
+        </p:style>
+        <p:txBody>
+          <a:bodyPr rtlCol="0" anchor="ctr"/>
+          <a:lstStyle/>
+          <a:p>
+            <a:pPr algn="ctr"/>
+          </a:p>
+        </p:txBody>
+      </p:sp>
+      <p:pic>
+        <p:nvPicPr>
+          <p:cNvPr id="6" name="Picture 5" descr="fig_theoretical_floor.png"/>
+          <p:cNvPicPr>
+            <a:picLocks noChangeAspect="1"/>
+          </p:cNvPicPr>
+          <p:nvPr/>
+        </p:nvPicPr>
+        <p:blipFill>
+          <a:blip r:embed="rId2"/>
+          <a:stretch>
+            <a:fillRect/>
+          </a:stretch>
+        </p:blipFill>
+        <p:spPr>
+          <a:xfrm>
+            <a:off x="2473807" y="1325880"/>
+            <a:ext cx="7244080" cy="1965960"/>
+          </a:xfrm>
+          <a:prstGeom prst="rect">
+            <a:avLst/>
+          </a:prstGeom>
+        </p:spPr>
+      </p:pic>
+      <p:sp>
+        <p:nvSpPr>
+          <p:cNvPr id="7" name="TextBox 6"/>
+          <p:cNvSpPr txBox="1"/>
+          <p:nvPr/>
+        </p:nvSpPr>
+        <p:spPr>
+          <a:xfrm>
+            <a:off x="548640" y="3429000"/>
+            <a:ext cx="11094415" cy="502920"/>
+          </a:xfrm>
+          <a:prstGeom prst="rect">
+            <a:avLst/>
+          </a:prstGeom>
+          <a:noFill/>
+        </p:spPr>
+        <p:txBody>
+          <a:bodyPr wrap="square" anchor="t">
+            <a:spAutoFit/>
+          </a:bodyPr>
+          <a:lstStyle/>
+          <a:p>
+            <a:pPr algn="l">
+              <a:lnSpc>
+                <a:spcPct val="100000"/>
+              </a:lnSpc>
+            </a:pPr>
+            <a:r>
+              <a:rPr sz="1350" b="1">
+                <a:solidFill>
+                  <a:srgbClr val="E8ECF4"/>
+                </a:solidFill>
+                <a:latin typeface="Noto Sans CJK KR"/>
+              </a:rPr>
+              <a:t>병렬화(exp52)만으로는 구조적으로 도달 불가 — 직렬 체인과 gs_mapping을 각각 65.1초 아래로 줄여야 한다(격차는 기존 추정보다 작아짐: 1.39배→1.32배).</a:t>
+            </a:r>
+          </a:p>
+        </p:txBody>
+      </p:sp>
+      <p:sp>
+        <p:nvSpPr>
+          <p:cNvPr id="8" name="Rounded Rectangle 7"/>
+          <p:cNvSpPr/>
+          <p:nvPr/>
+        </p:nvSpPr>
+        <p:spPr>
+          <a:xfrm>
+            <a:off x="548640" y="3794760"/>
+            <a:ext cx="1417320" cy="292608"/>
+          </a:xfrm>
+          <a:prstGeom prst="roundRect">
+            <a:avLst>
+              <a:gd name="adj" fmla="val 50000"/>
+            </a:avLst>
+          </a:prstGeom>
+          <a:solidFill>
+            <a:srgbClr val="1A1F2B"/>
+          </a:solidFill>
+          <a:ln w="12700">
+            <a:solidFill>
+              <a:srgbClr val="FFB454"/>
+            </a:solidFill>
+          </a:ln>
+          <a:effectLst/>
+        </p:spPr>
+        <p:style>
+          <a:lnRef idx="1">
+            <a:schemeClr val="accent1"/>
+          </a:lnRef>
+          <a:fillRef idx="3">
+            <a:schemeClr val="accent1"/>
+          </a:fillRef>
+          <a:effectRef idx="2">
+            <a:schemeClr val="accent1"/>
+          </a:effectRef>
+          <a:fontRef idx="minor">
+            <a:schemeClr val="lt1"/>
+          </a:fontRef>
+        </p:style>
+        <p:txBody>
+          <a:bodyPr rtlCol="0" anchor="ctr" lIns="45720" rIns="45720"/>
+          <a:lstStyle/>
+          <a:p>
+            <a:pPr algn="ctr"/>
+            <a:r>
+              <a:rPr sz="950" b="1">
+                <a:solidFill>
+                  <a:srgbClr val="FFB454"/>
+                </a:solidFill>
+                <a:latin typeface="Noto Sans CJK KR"/>
+              </a:rPr>
+              <a:t>EXP53 · 최우선</a:t>
+            </a:r>
+          </a:p>
+        </p:txBody>
+      </p:sp>
+      <p:sp>
+        <p:nvSpPr>
+          <p:cNvPr id="9" name="TextBox 8"/>
+          <p:cNvSpPr txBox="1"/>
+          <p:nvPr/>
+        </p:nvSpPr>
+        <p:spPr>
+          <a:xfrm>
+            <a:off x="2148840" y="3767328"/>
+            <a:ext cx="9494215" cy="457200"/>
+          </a:xfrm>
+          <a:prstGeom prst="rect">
+            <a:avLst/>
+          </a:prstGeom>
+          <a:noFill/>
+        </p:spPr>
+        <p:txBody>
+          <a:bodyPr wrap="square" anchor="ctr">
+            <a:spAutoFit/>
+          </a:bodyPr>
+          <a:lstStyle/>
+          <a:p>
+            <a:pPr algn="l">
+              <a:lnSpc>
+                <a:spcPct val="100000"/>
+              </a:lnSpc>
+            </a:pPr>
+            <a:r>
+              <a:rPr sz="1250" b="0">
+                <a:solidFill>
+                  <a:srgbClr val="E8ECF4"/>
+                </a:solidFill>
+                <a:latin typeface="Noto Sans CJK KR"/>
+              </a:rPr>
+              <a:t>Frontend 반복 축소(iters1/iters2) — bundle_adjust+update_op_forward가 frontend의 대부분. 직렬 체인을 줄이는 가장 직접적인 레버.</a:t>
+            </a:r>
+          </a:p>
+        </p:txBody>
+      </p:sp>
+      <p:sp>
+        <p:nvSpPr>
+          <p:cNvPr id="10" name="Rounded Rectangle 9"/>
+          <p:cNvSpPr/>
+          <p:nvPr/>
+        </p:nvSpPr>
+        <p:spPr>
+          <a:xfrm>
+            <a:off x="548640" y="4325112"/>
+            <a:ext cx="1417320" cy="292608"/>
+          </a:xfrm>
+          <a:prstGeom prst="roundRect">
+            <a:avLst>
+              <a:gd name="adj" fmla="val 50000"/>
+            </a:avLst>
+          </a:prstGeom>
+          <a:solidFill>
+            <a:srgbClr val="1A1F2B"/>
+          </a:solidFill>
+          <a:ln w="12700">
+            <a:solidFill>
+              <a:srgbClr val="4C86EA"/>
+            </a:solidFill>
+          </a:ln>
+          <a:effectLst/>
+        </p:spPr>
+        <p:style>
+          <a:lnRef idx="1">
+            <a:schemeClr val="accent1"/>
+          </a:lnRef>
+          <a:fillRef idx="3">
+            <a:schemeClr val="accent1"/>
+          </a:fillRef>
+          <a:effectRef idx="2">
+            <a:schemeClr val="accent1"/>
+          </a:effectRef>
+          <a:fontRef idx="minor">
+            <a:schemeClr val="lt1"/>
+          </a:fontRef>
+        </p:style>
+        <p:txBody>
+          <a:bodyPr rtlCol="0" anchor="ctr" lIns="45720" rIns="45720"/>
+          <a:lstStyle/>
+          <a:p>
+            <a:pPr algn="ctr"/>
+            <a:r>
+              <a:rPr sz="950" b="1">
+                <a:solidFill>
+                  <a:srgbClr val="4C86EA"/>
+                </a:solidFill>
+                <a:latin typeface="Noto Sans CJK KR"/>
+              </a:rPr>
+              <a:t>EXP53</a:t>
+            </a:r>
+          </a:p>
+        </p:txBody>
+      </p:sp>
+      <p:sp>
+        <p:nvSpPr>
+          <p:cNvPr id="11" name="TextBox 10"/>
+          <p:cNvSpPr txBox="1"/>
+          <p:nvPr/>
+        </p:nvSpPr>
+        <p:spPr>
+          <a:xfrm>
+            <a:off x="2148840" y="4297680"/>
+            <a:ext cx="9494215" cy="457200"/>
+          </a:xfrm>
+          <a:prstGeom prst="rect">
+            <a:avLst/>
+          </a:prstGeom>
+          <a:noFill/>
+        </p:spPr>
+        <p:txBody>
+          <a:bodyPr wrap="square" anchor="ctr">
+            <a:spAutoFit/>
+          </a:bodyPr>
+          <a:lstStyle/>
+          <a:p>
+            <a:pPr algn="l">
+              <a:lnSpc>
+                <a:spcPct val="100000"/>
+              </a:lnSpc>
+            </a:pPr>
+            <a:r>
+              <a:rPr sz="1250" b="0">
+                <a:solidFill>
+                  <a:srgbClr val="E8ECF4"/>
+                </a:solidFill>
+                <a:latin typeface="Noto Sans CJK KR"/>
+              </a:rPr>
+              <a:t>keyframe 밀도 억제(motion_filter.thresh) — keyframe 발생이 fps와 무관하다는 게 확인됐으니, 밀도 자체를 낮추는 게 fps를 낮추는 것보다 유효.</a:t>
+            </a:r>
+          </a:p>
+        </p:txBody>
+      </p:sp>
+      <p:sp>
+        <p:nvSpPr>
+          <p:cNvPr id="12" name="Rounded Rectangle 11"/>
+          <p:cNvSpPr/>
+          <p:nvPr/>
+        </p:nvSpPr>
+        <p:spPr>
+          <a:xfrm>
+            <a:off x="548640" y="4855464"/>
+            <a:ext cx="1417320" cy="292608"/>
+          </a:xfrm>
+          <a:prstGeom prst="roundRect">
+            <a:avLst>
+              <a:gd name="adj" fmla="val 50000"/>
+            </a:avLst>
+          </a:prstGeom>
+          <a:solidFill>
+            <a:srgbClr val="1A1F2B"/>
+          </a:solidFill>
+          <a:ln w="12700">
+            <a:solidFill>
+              <a:srgbClr val="8B95AB"/>
+            </a:solidFill>
+          </a:ln>
+          <a:effectLst/>
+        </p:spPr>
+        <p:style>
+          <a:lnRef idx="1">
+            <a:schemeClr val="accent1"/>
+          </a:lnRef>
+          <a:fillRef idx="3">
+            <a:schemeClr val="accent1"/>
+          </a:fillRef>
+          <a:effectRef idx="2">
+            <a:schemeClr val="accent1"/>
+          </a:effectRef>
+          <a:fontRef idx="minor">
+            <a:schemeClr val="lt1"/>
+          </a:fontRef>
+        </p:style>
+        <p:txBody>
+          <a:bodyPr rtlCol="0" anchor="ctr" lIns="45720" rIns="45720"/>
+          <a:lstStyle/>
+          <a:p>
+            <a:pPr algn="ctr"/>
+            <a:r>
+              <a:rPr sz="950" b="1">
+                <a:solidFill>
+                  <a:srgbClr val="8B95AB"/>
+                </a:solidFill>
+                <a:latin typeface="Noto Sans CJK KR"/>
+              </a:rPr>
+              <a:t>EXP52 · 해소됨</a:t>
+            </a:r>
+          </a:p>
+        </p:txBody>
+      </p:sp>
+      <p:sp>
+        <p:nvSpPr>
+          <p:cNvPr id="13" name="TextBox 12"/>
+          <p:cNvSpPr txBox="1"/>
+          <p:nvPr/>
+        </p:nvSpPr>
+        <p:spPr>
+          <a:xfrm>
+            <a:off x="2148840" y="4828032"/>
+            <a:ext cx="9494215" cy="457200"/>
+          </a:xfrm>
+          <a:prstGeom prst="rect">
+            <a:avLst/>
+          </a:prstGeom>
+          <a:noFill/>
+        </p:spPr>
+        <p:txBody>
+          <a:bodyPr wrap="square" anchor="ctr">
+            <a:spAutoFit/>
+          </a:bodyPr>
+          <a:lstStyle/>
+          <a:p>
+            <a:pPr algn="l">
+              <a:lnSpc>
+                <a:spcPct val="100000"/>
+              </a:lnSpc>
+            </a:pPr>
+            <a:r>
+              <a:rPr sz="1250" b="0">
+                <a:solidFill>
+                  <a:srgbClr val="E8ECF4"/>
+                </a:solidFill>
+                <a:latin typeface="Noto Sans CJK KR"/>
+              </a:rPr>
+              <a:t>27.0초 오버헤드 → 리더 프로세스 타이밍 버그로 확인·수정됨(21.1초 미계측 잔여가 0.2초로 해소). 더 이상 미스터리 아님.</a:t>
+            </a:r>
+          </a:p>
+        </p:txBody>
+      </p:sp>
+      <p:sp>
+        <p:nvSpPr>
+          <p:cNvPr id="14" name="Rounded Rectangle 13"/>
+          <p:cNvSpPr/>
+          <p:nvPr/>
+        </p:nvSpPr>
+        <p:spPr>
+          <a:xfrm>
+            <a:off x="548640" y="5385816"/>
+            <a:ext cx="1417320" cy="292608"/>
+          </a:xfrm>
+          <a:prstGeom prst="roundRect">
+            <a:avLst>
+              <a:gd name="adj" fmla="val 50000"/>
+            </a:avLst>
+          </a:prstGeom>
+          <a:solidFill>
+            <a:srgbClr val="1A1F2B"/>
+          </a:solidFill>
+          <a:ln w="12700">
+            <a:solidFill>
+              <a:srgbClr val="E8ECF4"/>
+            </a:solidFill>
+          </a:ln>
+          <a:effectLst/>
+        </p:spPr>
+        <p:style>
+          <a:lnRef idx="1">
+            <a:schemeClr val="accent1"/>
+          </a:lnRef>
+          <a:fillRef idx="3">
+            <a:schemeClr val="accent1"/>
+          </a:fillRef>
+          <a:effectRef idx="2">
+            <a:schemeClr val="accent1"/>
+          </a:effectRef>
+          <a:fontRef idx="minor">
+            <a:schemeClr val="lt1"/>
+          </a:fontRef>
+        </p:style>
+        <p:txBody>
+          <a:bodyPr rtlCol="0" anchor="ctr" lIns="45720" rIns="45720"/>
+          <a:lstStyle/>
+          <a:p>
+            <a:pPr algn="ctr"/>
+            <a:r>
+              <a:rPr sz="950" b="1">
+                <a:solidFill>
+                  <a:srgbClr val="E8ECF4"/>
+                </a:solidFill>
+                <a:latin typeface="Noto Sans CJK KR"/>
+              </a:rPr>
+              <a:t>EXP53 · 신규</a:t>
+            </a:r>
+          </a:p>
+        </p:txBody>
+      </p:sp>
+      <p:sp>
+        <p:nvSpPr>
+          <p:cNvPr id="15" name="TextBox 14"/>
+          <p:cNvSpPr txBox="1"/>
+          <p:nvPr/>
+        </p:nvSpPr>
+        <p:spPr>
+          <a:xfrm>
+            <a:off x="2148840" y="5358384"/>
+            <a:ext cx="9494215" cy="457200"/>
+          </a:xfrm>
+          <a:prstGeom prst="rect">
+            <a:avLst/>
+          </a:prstGeom>
+          <a:noFill/>
+        </p:spPr>
+        <p:txBody>
+          <a:bodyPr wrap="square" anchor="ctr">
+            <a:spAutoFit/>
+          </a:bodyPr>
+          <a:lstStyle/>
+          <a:p>
+            <a:pPr algn="l">
+              <a:lnSpc>
+                <a:spcPct val="100000"/>
+              </a:lnSpc>
+            </a:pPr>
+            <a:r>
+              <a:rPr sz="1250" b="0">
+                <a:solidFill>
+                  <a:srgbClr val="E8ECF4"/>
+                </a:solidFill>
+                <a:latin typeface="Noto Sans CJK KR"/>
+              </a:rPr>
+              <a:t>축A~D를 gs_parallel 켠 상태/끈 상태 둘 다에서 측정 — frontend가 경합 시 +57% 느려짐이 확인됐으니, 순차 측정만으론 병렬 실전 효과를 과대추정할 수 있음.</a:t>
+            </a:r>
+          </a:p>
+        </p:txBody>
+      </p:sp>
+      <p:sp>
+        <p:nvSpPr>
+          <p:cNvPr id="16" name="Rounded Rectangle 15"/>
+          <p:cNvSpPr/>
+          <p:nvPr/>
+        </p:nvSpPr>
+        <p:spPr>
+          <a:xfrm>
+            <a:off x="548640" y="5916168"/>
+            <a:ext cx="1417320" cy="292608"/>
+          </a:xfrm>
+          <a:prstGeom prst="roundRect">
+            <a:avLst>
+              <a:gd name="adj" fmla="val 50000"/>
+            </a:avLst>
+          </a:prstGeom>
+          <a:solidFill>
+            <a:srgbClr val="1A1F2B"/>
+          </a:solidFill>
+          <a:ln w="12700">
+            <a:solidFill>
+              <a:srgbClr val="EF6A5C"/>
+            </a:solidFill>
+          </a:ln>
+          <a:effectLst/>
+        </p:spPr>
+        <p:style>
+          <a:lnRef idx="1">
+            <a:schemeClr val="accent1"/>
+          </a:lnRef>
+          <a:fillRef idx="3">
+            <a:schemeClr val="accent1"/>
+          </a:fillRef>
+          <a:effectRef idx="2">
+            <a:schemeClr val="accent1"/>
+          </a:effectRef>
+          <a:fontRef idx="minor">
+            <a:schemeClr val="lt1"/>
+          </a:fontRef>
+        </p:style>
+        <p:txBody>
+          <a:bodyPr rtlCol="0" anchor="ctr" lIns="45720" rIns="45720"/>
+          <a:lstStyle/>
+          <a:p>
+            <a:pPr algn="ctr"/>
+            <a:r>
+              <a:rPr sz="950" b="1">
+                <a:solidFill>
+                  <a:srgbClr val="EF6A5C"/>
+                </a:solidFill>
+                <a:latin typeface="Noto Sans CJK KR"/>
+              </a:rPr>
+              <a:t>EXP52 · 계속</a:t>
+            </a:r>
+          </a:p>
+        </p:txBody>
+      </p:sp>
+      <p:sp>
+        <p:nvSpPr>
+          <p:cNvPr id="17" name="TextBox 16"/>
+          <p:cNvSpPr txBox="1"/>
+          <p:nvPr/>
+        </p:nvSpPr>
+        <p:spPr>
+          <a:xfrm>
+            <a:off x="2148840" y="5888736"/>
+            <a:ext cx="9494215" cy="457200"/>
+          </a:xfrm>
+          <a:prstGeom prst="rect">
+            <a:avLst/>
+          </a:prstGeom>
+          <a:noFill/>
+        </p:spPr>
+        <p:txBody>
+          <a:bodyPr wrap="square" anchor="ctr">
+            <a:spAutoFit/>
+          </a:bodyPr>
+          <a:lstStyle/>
+          <a:p>
+            <a:pPr algn="l">
+              <a:lnSpc>
+                <a:spcPct val="100000"/>
+              </a:lnSpc>
+            </a:pPr>
+            <a:r>
+              <a:rPr sz="1250" b="0">
+                <a:solidFill>
+                  <a:srgbClr val="E8ECF4"/>
+                </a:solidFill>
+                <a:latin typeface="Noto Sans CJK KR"/>
+              </a:rPr>
+              <a:t>gs_mapping 자체 연산량 감소 — iteration 수·해상도·densify 빈도. RTX 5090에서도 저자 자신이 12.02fps(미달)였던 부분이라 GPU 업그레이드만으론 부족.</a:t>
+            </a:r>
+          </a:p>
+        </p:txBody>
+      </p:sp>
+    </p:spTree>
+  </p:cSld>
+  <p:clrMapOvr>
+    <a:masterClrMapping/>
+  </p:clrMapOvr>
+</p:sld>
+</file>
+
+<file path=ppt/slides/slide9.xml><?xml version="1.0" encoding="utf-8"?>
+<p:sld xmlns:a="http://schemas.openxmlformats.org/drawingml/2006/main" xmlns:p="http://schemas.openxmlformats.org/presentationml/2006/main" xmlns:r="http://schemas.openxmlformats.org/officeDocument/2006/relationships">
+  <p:cSld>
+    <p:spTree>
+      <p:nvGrpSpPr>
+        <p:cNvPr id="1" name=""/>
+        <p:cNvGrpSpPr/>
+        <p:nvPr/>
+      </p:nvGrpSpPr>
+      <p:grpSpPr/>
+      <p:sp>
+        <p:nvSpPr>
+          <p:cNvPr id="2" name="Rectangle 1"/>
+          <p:cNvSpPr/>
+          <p:nvPr/>
+        </p:nvSpPr>
+        <p:spPr>
+          <a:xfrm>
+            <a:off x="0" y="0"/>
+            <a:ext cx="12191695" cy="6858000"/>
+          </a:xfrm>
+          <a:prstGeom prst="rect">
+            <a:avLst/>
+          </a:prstGeom>
+          <a:solidFill>
+            <a:srgbClr val="12151C"/>
+          </a:solidFill>
+          <a:ln>
+            <a:noFill/>
+          </a:ln>
+          <a:effectLst/>
+        </p:spPr>
+        <p:style>
+          <a:lnRef idx="1">
+            <a:schemeClr val="accent1"/>
+          </a:lnRef>
+          <a:fillRef idx="3">
+            <a:schemeClr val="accent1"/>
+          </a:fillRef>
+          <a:effectRef idx="2">
+            <a:schemeClr val="accent1"/>
+          </a:effectRef>
+          <a:fontRef idx="minor">
+            <a:schemeClr val="lt1"/>
+          </a:fontRef>
+        </p:style>
+        <p:txBody>
+          <a:bodyPr rtlCol="0" anchor="ctr"/>
+          <a:lstStyle/>
+          <a:p>
+            <a:pPr algn="ctr"/>
+          </a:p>
+        </p:txBody>
+      </p:sp>
+      <p:sp>
+        <p:nvSpPr>
+          <p:cNvPr id="3" name="TextBox 2"/>
+          <p:cNvSpPr txBox="1"/>
+          <p:nvPr/>
+        </p:nvSpPr>
+        <p:spPr>
+          <a:xfrm>
+            <a:off x="548640" y="320040"/>
+            <a:ext cx="11094415" cy="292608"/>
+          </a:xfrm>
+          <a:prstGeom prst="rect">
+            <a:avLst/>
+          </a:prstGeom>
+          <a:noFill/>
+        </p:spPr>
+        <p:txBody>
+          <a:bodyPr wrap="square" anchor="t">
+            <a:spAutoFit/>
+          </a:bodyPr>
+          <a:lstStyle/>
+          <a:p>
+            <a:pPr algn="l">
+              <a:lnSpc>
+                <a:spcPct val="100000"/>
+              </a:lnSpc>
+            </a:pPr>
+            <a:r>
+              <a:rPr sz="1200" b="1">
+                <a:solidFill>
+                  <a:srgbClr val="FFB454"/>
+                </a:solidFill>
+                <a:latin typeface="Noto Sans CJK KR"/>
+              </a:rPr>
+              <a:t>COMPONENT BREAKDOWN</a:t>
+            </a:r>
+          </a:p>
+        </p:txBody>
+      </p:sp>
+      <p:sp>
+        <p:nvSpPr>
+          <p:cNvPr id="4" name="TextBox 3"/>
+          <p:cNvSpPr txBox="1"/>
+          <p:nvPr/>
+        </p:nvSpPr>
+        <p:spPr>
+          <a:xfrm>
+            <a:off x="548640" y="566928"/>
+            <a:ext cx="11094415" cy="548640"/>
+          </a:xfrm>
+          <a:prstGeom prst="rect">
+            <a:avLst/>
+          </a:prstGeom>
+          <a:noFill/>
+        </p:spPr>
+        <p:txBody>
+          <a:bodyPr wrap="square" anchor="t">
+            <a:spAutoFit/>
+          </a:bodyPr>
+          <a:lstStyle/>
+          <a:p>
+            <a:pPr algn="l">
+              <a:lnSpc>
+                <a:spcPct val="100000"/>
+              </a:lnSpc>
+            </a:pPr>
+            <a:r>
+              <a:rPr sz="2200" b="1">
+                <a:solidFill>
+                  <a:srgbClr val="E8ECF4"/>
+                </a:solidFill>
+                <a:latin typeface="Noto Sans CJK KR"/>
+              </a:rPr>
+              <a:t>구성요소별 세부 분해 (정정판)</a:t>
             </a:r>
           </a:p>
         </p:txBody>

</xml_diff>